<commit_message>
docs(pitch-agentic-procurement): add contact email to slide 14 in HTML and PPTX
</commit_message>
<xml_diff>
--- a/docs/publish/pitch-agentic-procurement/Finux-Labs-Procurement-AI-Pitch-15-Slides.pptx
+++ b/docs/publish/pitch-agentic-procurement/Finux-Labs-Procurement-AI-Pitch-15-Slides.pptx
@@ -15630,6 +15630,15 @@
               </a:rPr>
               <a:t>Ju He (Terence), founder and builder</a:t>
             </a:r>
+            <a:r>
+              <a:rPr sz="1725">
+                <a:solidFill>
+                  <a:srgbClr val="4B526F"/>
+                </a:solidFill>
+                <a:latin typeface="DejaVu Sans"/>
+              </a:rPr>
+              <a:t> · Contact: juhe.terence@gmail.com</a:t>
+            </a:r>
           </a:p>
         </p:txBody>
       </p:sp>

</xml_diff>

<commit_message>
feat(pitch-agentic-procurement): add 2-D barcode (QR code) for live deck URL on slide 14
</commit_message>
<xml_diff>
--- a/docs/publish/pitch-agentic-procurement/Finux-Labs-Procurement-AI-Pitch-15-Slides.pptx
+++ b/docs/publish/pitch-agentic-procurement/Finux-Labs-Procurement-AI-Pitch-15-Slides.pptx
@@ -17723,6 +17723,30 @@
           </a:p>
         </p:txBody>
       </p:sp>
+      <p:pic xmlns:a="http://schemas.openxmlformats.org/drawingml/2006/main" xmlns:r="http://schemas.openxmlformats.org/officeDocument/2006/relationships">
+        <p:nvPicPr>
+          <p:cNvPr id="15" name="Picture 14" descr="qrcode_pitch.png"/>
+          <p:cNvPicPr>
+            <a:picLocks noChangeAspect="1"/>
+          </p:cNvPicPr>
+          <p:nvPr/>
+        </p:nvPicPr>
+        <p:blipFill>
+          <a:blip r:embed="rId3"/>
+          <a:stretch>
+            <a:fillRect/>
+          </a:stretch>
+        </p:blipFill>
+        <p:spPr>
+          <a:xfrm>
+            <a:off x="4127500" y="4635500"/>
+            <a:ext cx="914400" cy="914400"/>
+          </a:xfrm>
+          <a:prstGeom prst="rect">
+            <a:avLst/>
+          </a:prstGeom>
+        </p:spPr>
+      </p:pic>
     </p:spTree>
     <p:extLst>
       <p:ext uri="{BB962C8B-B14F-4D97-AF65-F5344CB8AC3E}">

</xml_diff>

<commit_message>
Update cover title to Procurement AI, fix mobile cover background, and sync slide 14 barcode to PDF and PPTX
</commit_message>
<xml_diff>
--- a/docs/publish/pitch-agentic-procurement/Finux-Labs-Procurement-AI-Pitch-15-Slides.pptx
+++ b/docs/publish/pitch-agentic-procurement/Finux-Labs-Procurement-AI-Pitch-15-Slides.pptx
@@ -5483,14 +5483,6 @@
               </a:defRPr>
             </a:pPr>
             <a:r>
-              <a:rPr sz="3825" b="1">
-                <a:solidFill>
-                  <a:srgbClr val="F6F7FF"/>
-                </a:solidFill>
-                <a:latin typeface="DejaVu Sans"/>
-                <a:ea typeface="DejaVu Sans"/>
-                <a:cs typeface="DejaVu Sans"/>
-              </a:rPr>
               <a:t>Agentic Negotiator,</a:t>
             </a:r>
           </a:p>
@@ -5510,42 +5502,7 @@
               </a:defRPr>
             </a:pPr>
             <a:r>
-              <a:rPr sz="3825" b="1">
-                <a:solidFill>
-                  <a:srgbClr val="F6F7FF"/>
-                </a:solidFill>
-                <a:latin typeface="DejaVu Sans"/>
-                <a:ea typeface="DejaVu Sans"/>
-                <a:cs typeface="DejaVu Sans"/>
-              </a:rPr>
-              <a:t>Procurement</a:t>
-            </a:r>
-          </a:p>
-          <a:p xmlns:a="http://schemas.openxmlformats.org/drawingml/2006/main">
-            <a:pPr algn="l">
-              <a:lnSpc>
-                <a:spcPct val="112000"/>
-              </a:lnSpc>
-              <a:buNone/>
-              <a:defRPr sz="4125" b="1">
-                <a:solidFill>
-                  <a:srgbClr val="F6F7FF"/>
-                </a:solidFill>
-                <a:latin typeface="DejaVu Sans"/>
-                <a:ea typeface="DejaVu Sans"/>
-                <a:cs typeface="DejaVu Sans"/>
-              </a:defRPr>
-            </a:pPr>
-            <a:r>
-              <a:rPr sz="3825" b="1">
-                <a:solidFill>
-                  <a:srgbClr val="F6F7FF"/>
-                </a:solidFill>
-                <a:latin typeface="DejaVu Sans"/>
-                <a:ea typeface="DejaVu Sans"/>
-                <a:cs typeface="DejaVu Sans"/>
-              </a:rPr>
-              <a:t>Accelerator</a:t>
+              <a:t>Procurement AI</a:t>
             </a:r>
           </a:p>
         </p:txBody>
@@ -15605,39 +15562,16 @@
             </a:lvl9pPr>
           </a:lstStyle>
           <a:p xmlns:a="http://schemas.openxmlformats.org/drawingml/2006/main">
-            <a:pPr algn="l">
-              <a:lnSpc>
-                <a:spcPct val="112000"/>
-              </a:lnSpc>
-              <a:buNone/>
-              <a:defRPr sz="1725" b="0">
-                <a:solidFill>
-                  <a:srgbClr val="4B526F"/>
-                </a:solidFill>
-                <a:latin typeface="DejaVu Sans"/>
-                <a:ea typeface="DejaVu Sans"/>
-                <a:cs typeface="DejaVu Sans"/>
+            <a:pPr>
+              <a:defRPr sz="1300">
+                <a:solidFill>
+                  <a:srgbClr val="5A6578"/>
+                </a:solidFill>
+                <a:latin typeface="DejaVu Sans"/>
               </a:defRPr>
             </a:pPr>
             <a:r>
-              <a:rPr sz="1725" b="0">
-                <a:solidFill>
-                  <a:srgbClr val="4B526F"/>
-                </a:solidFill>
-                <a:latin typeface="DejaVu Sans"/>
-                <a:ea typeface="DejaVu Sans"/>
-                <a:cs typeface="DejaVu Sans"/>
-              </a:rPr>
-              <a:t>Ju He (Terence), founder and builder</a:t>
-            </a:r>
-            <a:r>
-              <a:rPr sz="1725">
-                <a:solidFill>
-                  <a:srgbClr val="4B526F"/>
-                </a:solidFill>
-                <a:latin typeface="DejaVu Sans"/>
-              </a:rPr>
-              <a:t> · Contact: juhe.terence@gmail.com</a:t>
+              <a:t>Ju He (Terence), founder and builder · juhe.terence@gmail.com</a:t>
             </a:r>
           </a:p>
         </p:txBody>
@@ -15986,1746 +15920,804 @@
           </a:p>
         </p:txBody>
       </p:sp>
-      <p:sp>
+      <p:sp xmlns:a="http://schemas.openxmlformats.org/drawingml/2006/main">
         <p:nvSpPr>
-          <p:cNvPr id="5" name="founder-tenure">
-            <a:extLst xmlns:a="http://schemas.openxmlformats.org/drawingml/2006/main">
-              <a:ext uri="{FF2B5EF4-FFF2-40B4-BE49-F238E27FC236}">
-                <a16:creationId xmlns:a16="http://schemas.microsoft.com/office/drawing/2014/main" id="{91FD7EDE-B9DB-43DF-889B-FAF930D151AB}"/>
-              </a:ext>
-            </a:extLst>
-          </p:cNvPr>
-          <p:cNvSpPr>
-            <a:spLocks xmlns:a="http://schemas.openxmlformats.org/drawingml/2006/main" noGrp="1"/>
-          </p:cNvSpPr>
+          <p:cNvPr id="15" name="Rectangle 14"/>
+          <p:cNvSpPr/>
           <p:nvPr/>
         </p:nvSpPr>
         <p:spPr>
-          <a:xfrm xmlns:a="http://schemas.openxmlformats.org/drawingml/2006/main">
-            <a:off x="552450" y="2047875"/>
-            <a:ext cx="4191000" cy="857250"/>
+          <a:xfrm>
+            <a:off x="548640" y="1874519"/>
+            <a:ext cx="3520440" cy="4343400"/>
           </a:xfrm>
-          <a:prstGeom xmlns:a="http://schemas.openxmlformats.org/drawingml/2006/main" prst="rect">
+          <a:prstGeom prst="rect">
             <a:avLst/>
           </a:prstGeom>
-          <a:noFill xmlns:a="http://schemas.openxmlformats.org/drawingml/2006/main"/>
-          <a:ln xmlns:a="http://schemas.openxmlformats.org/drawingml/2006/main" w="0">
-            <a:noFill/>
-            <a:prstDash val="solid"/>
+          <a:solidFill>
+            <a:srgbClr val="FFFFFF"/>
+          </a:solidFill>
+          <a:ln w="12700">
+            <a:solidFill>
+              <a:srgbClr val="DCE1EE"/>
+            </a:solidFill>
           </a:ln>
         </p:spPr>
+        <p:style>
+          <a:lnRef idx="1">
+            <a:schemeClr val="accent1"/>
+          </a:lnRef>
+          <a:fillRef idx="3">
+            <a:schemeClr val="accent1"/>
+          </a:fillRef>
+          <a:effectRef idx="2">
+            <a:schemeClr val="accent1"/>
+          </a:effectRef>
+          <a:fontRef idx="minor">
+            <a:schemeClr val="lt1"/>
+          </a:fontRef>
+        </p:style>
         <p:txBody>
-          <a:bodyPr xmlns:a="http://schemas.openxmlformats.org/drawingml/2006/main" wrap="square" lIns="0" tIns="0" rIns="0" bIns="0" anchor="t">
-            <a:noAutofit/>
+          <a:bodyPr rtlCol="0" anchor="ctr"/>
+          <a:lstStyle/>
+          <a:p>
+            <a:pPr algn="ctr"/>
+          </a:p>
+        </p:txBody>
+      </p:sp>
+      <p:sp xmlns:a="http://schemas.openxmlformats.org/drawingml/2006/main">
+        <p:nvSpPr>
+          <p:cNvPr id="16" name="Rectangle 15"/>
+          <p:cNvSpPr/>
+          <p:nvPr/>
+        </p:nvSpPr>
+        <p:spPr>
+          <a:xfrm>
+            <a:off x="548640" y="1874519"/>
+            <a:ext cx="73152" cy="4343400"/>
+          </a:xfrm>
+          <a:prstGeom prst="rect">
+            <a:avLst/>
+          </a:prstGeom>
+          <a:solidFill>
+            <a:srgbClr val="6C5CE7"/>
+          </a:solidFill>
+          <a:ln>
+            <a:noFill/>
+          </a:ln>
+        </p:spPr>
+        <p:style>
+          <a:lnRef idx="1">
+            <a:schemeClr val="accent1"/>
+          </a:lnRef>
+          <a:fillRef idx="3">
+            <a:schemeClr val="accent1"/>
+          </a:fillRef>
+          <a:effectRef idx="2">
+            <a:schemeClr val="accent1"/>
+          </a:effectRef>
+          <a:fontRef idx="minor">
+            <a:schemeClr val="lt1"/>
+          </a:fontRef>
+        </p:style>
+        <p:txBody>
+          <a:bodyPr rtlCol="0" anchor="ctr"/>
+          <a:lstStyle/>
+          <a:p>
+            <a:pPr algn="ctr"/>
+          </a:p>
+        </p:txBody>
+      </p:sp>
+      <p:sp xmlns:a="http://schemas.openxmlformats.org/drawingml/2006/main">
+        <p:nvSpPr>
+          <p:cNvPr id="17" name="TextBox 16"/>
+          <p:cNvSpPr txBox="1"/>
+          <p:nvPr/>
+        </p:nvSpPr>
+        <p:spPr>
+          <a:xfrm>
+            <a:off x="777240" y="2011680"/>
+            <a:ext cx="3108960" cy="594360"/>
+          </a:xfrm>
+          <a:prstGeom prst="rect">
+            <a:avLst/>
+          </a:prstGeom>
+          <a:noFill/>
+        </p:spPr>
+        <p:txBody>
+          <a:bodyPr wrap="none">
+            <a:spAutoFit/>
           </a:bodyPr>
-          <a:lstStyle xmlns:a="http://schemas.openxmlformats.org/drawingml/2006/main">
-            <a:defPPr algn="l">
-              <a:defRPr sz="4650" b="1">
-                <a:solidFill>
-                  <a:srgbClr val="171C3D"/>
-                </a:solidFill>
-                <a:latin typeface="DejaVu Sans"/>
-                <a:ea typeface="DejaVu Sans"/>
-                <a:cs typeface="DejaVu Sans"/>
-              </a:defRPr>
-            </a:defPPr>
-            <a:lvl1pPr algn="l">
-              <a:buNone/>
-              <a:defRPr sz="4650" b="1">
-                <a:solidFill>
-                  <a:srgbClr val="171C3D"/>
-                </a:solidFill>
-                <a:latin typeface="DejaVu Sans"/>
-                <a:ea typeface="DejaVu Sans"/>
-                <a:cs typeface="DejaVu Sans"/>
-              </a:defRPr>
-            </a:lvl1pPr>
-            <a:lvl2pPr algn="l">
-              <a:buNone/>
-              <a:defRPr sz="4650" b="1">
-                <a:solidFill>
-                  <a:srgbClr val="171C3D"/>
-                </a:solidFill>
-                <a:latin typeface="DejaVu Sans"/>
-                <a:ea typeface="DejaVu Sans"/>
-                <a:cs typeface="DejaVu Sans"/>
-              </a:defRPr>
-            </a:lvl2pPr>
-            <a:lvl3pPr algn="l">
-              <a:buNone/>
-              <a:defRPr sz="4650" b="1">
-                <a:solidFill>
-                  <a:srgbClr val="171C3D"/>
-                </a:solidFill>
-                <a:latin typeface="DejaVu Sans"/>
-                <a:ea typeface="DejaVu Sans"/>
-                <a:cs typeface="DejaVu Sans"/>
-              </a:defRPr>
-            </a:lvl3pPr>
-            <a:lvl4pPr algn="l">
-              <a:buNone/>
-              <a:defRPr sz="4650" b="1">
-                <a:solidFill>
-                  <a:srgbClr val="171C3D"/>
-                </a:solidFill>
-                <a:latin typeface="DejaVu Sans"/>
-                <a:ea typeface="DejaVu Sans"/>
-                <a:cs typeface="DejaVu Sans"/>
-              </a:defRPr>
-            </a:lvl4pPr>
-            <a:lvl5pPr algn="l">
-              <a:buNone/>
-              <a:defRPr sz="4650" b="1">
-                <a:solidFill>
-                  <a:srgbClr val="171C3D"/>
-                </a:solidFill>
-                <a:latin typeface="DejaVu Sans"/>
-                <a:ea typeface="DejaVu Sans"/>
-                <a:cs typeface="DejaVu Sans"/>
-              </a:defRPr>
-            </a:lvl5pPr>
-            <a:lvl6pPr algn="l">
-              <a:buNone/>
-              <a:defRPr sz="4650" b="1">
-                <a:solidFill>
-                  <a:srgbClr val="171C3D"/>
-                </a:solidFill>
-                <a:latin typeface="DejaVu Sans"/>
-                <a:ea typeface="DejaVu Sans"/>
-                <a:cs typeface="DejaVu Sans"/>
-              </a:defRPr>
-            </a:lvl6pPr>
-            <a:lvl7pPr algn="l">
-              <a:buNone/>
-              <a:defRPr sz="4650" b="1">
-                <a:solidFill>
-                  <a:srgbClr val="171C3D"/>
-                </a:solidFill>
-                <a:latin typeface="DejaVu Sans"/>
-                <a:ea typeface="DejaVu Sans"/>
-                <a:cs typeface="DejaVu Sans"/>
-              </a:defRPr>
-            </a:lvl7pPr>
-            <a:lvl8pPr algn="l">
-              <a:buNone/>
-              <a:defRPr sz="4650" b="1">
-                <a:solidFill>
-                  <a:srgbClr val="171C3D"/>
-                </a:solidFill>
-                <a:latin typeface="DejaVu Sans"/>
-                <a:ea typeface="DejaVu Sans"/>
-                <a:cs typeface="DejaVu Sans"/>
-              </a:defRPr>
-            </a:lvl8pPr>
-            <a:lvl9pPr algn="l">
-              <a:buNone/>
-              <a:defRPr sz="4650" b="1">
-                <a:solidFill>
-                  <a:srgbClr val="171C3D"/>
-                </a:solidFill>
-                <a:latin typeface="DejaVu Sans"/>
-                <a:ea typeface="DejaVu Sans"/>
-                <a:cs typeface="DejaVu Sans"/>
-              </a:defRPr>
-            </a:lvl9pPr>
-          </a:lstStyle>
-          <a:p xmlns:a="http://schemas.openxmlformats.org/drawingml/2006/main">
+          <a:lstStyle/>
+          <a:p>
             <a:pPr algn="l">
-              <a:lnSpc>
-                <a:spcPct val="112000"/>
-              </a:lnSpc>
-              <a:buNone/>
-              <a:defRPr sz="4650" b="1">
-                <a:solidFill>
-                  <a:srgbClr val="171C3D"/>
-                </a:solidFill>
-                <a:latin typeface="DejaVu Sans"/>
-                <a:ea typeface="DejaVu Sans"/>
-                <a:cs typeface="DejaVu Sans"/>
+              <a:defRPr sz="3600" b="1">
+                <a:solidFill>
+                  <a:srgbClr val="6C5CE7"/>
+                </a:solidFill>
+                <a:latin typeface="DejaVu Sans"/>
               </a:defRPr>
             </a:pPr>
             <a:r>
-              <a:rPr sz="4650" b="1">
-                <a:solidFill>
-                  <a:srgbClr val="171C3D"/>
-                </a:solidFill>
-                <a:latin typeface="DejaVu Sans"/>
-                <a:ea typeface="DejaVu Sans"/>
-                <a:cs typeface="DejaVu Sans"/>
-              </a:rPr>
               <a:t>10+ years</a:t>
             </a:r>
           </a:p>
         </p:txBody>
       </p:sp>
-      <p:sp>
+      <p:sp xmlns:a="http://schemas.openxmlformats.org/drawingml/2006/main">
         <p:nvSpPr>
-          <p:cNvPr id="6" name="founder-experience">
-            <a:extLst xmlns:a="http://schemas.openxmlformats.org/drawingml/2006/main">
-              <a:ext uri="{FF2B5EF4-FFF2-40B4-BE49-F238E27FC236}">
-                <a16:creationId xmlns:a16="http://schemas.microsoft.com/office/drawing/2014/main" id="{9AC29550-6744-40F7-9913-691DC2B5FF37}"/>
-              </a:ext>
-            </a:extLst>
-          </p:cNvPr>
-          <p:cNvSpPr>
-            <a:spLocks xmlns:a="http://schemas.openxmlformats.org/drawingml/2006/main" noGrp="1"/>
-          </p:cNvSpPr>
+          <p:cNvPr id="18" name="TextBox 17"/>
+          <p:cNvSpPr txBox="1"/>
           <p:nvPr/>
         </p:nvSpPr>
         <p:spPr>
-          <a:xfrm xmlns:a="http://schemas.openxmlformats.org/drawingml/2006/main">
-            <a:off x="571500" y="3076575"/>
-            <a:ext cx="4476750" cy="1228725"/>
+          <a:xfrm>
+            <a:off x="777240" y="2697480"/>
+            <a:ext cx="3108960" cy="1097280"/>
           </a:xfrm>
-          <a:prstGeom xmlns:a="http://schemas.openxmlformats.org/drawingml/2006/main" prst="rect">
+          <a:prstGeom prst="rect">
             <a:avLst/>
           </a:prstGeom>
-          <a:noFill xmlns:a="http://schemas.openxmlformats.org/drawingml/2006/main"/>
-          <a:ln xmlns:a="http://schemas.openxmlformats.org/drawingml/2006/main" w="0">
-            <a:noFill/>
-            <a:prstDash val="solid"/>
-          </a:ln>
+          <a:noFill/>
         </p:spPr>
         <p:txBody>
-          <a:bodyPr xmlns:a="http://schemas.openxmlformats.org/drawingml/2006/main" wrap="square" lIns="0" tIns="0" rIns="0" bIns="0" anchor="t">
-            <a:noAutofit/>
+          <a:bodyPr wrap="square">
+            <a:spAutoFit/>
           </a:bodyPr>
-          <a:lstStyle xmlns:a="http://schemas.openxmlformats.org/drawingml/2006/main">
-            <a:defPPr algn="l">
-              <a:defRPr sz="1950" b="0">
-                <a:solidFill>
-                  <a:srgbClr val="4B526F"/>
-                </a:solidFill>
-                <a:latin typeface="DejaVu Sans"/>
-                <a:ea typeface="DejaVu Sans"/>
-                <a:cs typeface="DejaVu Sans"/>
-              </a:defRPr>
-            </a:defPPr>
-            <a:lvl1pPr algn="l">
-              <a:buNone/>
-              <a:defRPr sz="1950" b="0">
-                <a:solidFill>
-                  <a:srgbClr val="4B526F"/>
-                </a:solidFill>
-                <a:latin typeface="DejaVu Sans"/>
-                <a:ea typeface="DejaVu Sans"/>
-                <a:cs typeface="DejaVu Sans"/>
-              </a:defRPr>
-            </a:lvl1pPr>
-            <a:lvl2pPr algn="l">
-              <a:buNone/>
-              <a:defRPr sz="1950" b="0">
-                <a:solidFill>
-                  <a:srgbClr val="4B526F"/>
-                </a:solidFill>
-                <a:latin typeface="DejaVu Sans"/>
-                <a:ea typeface="DejaVu Sans"/>
-                <a:cs typeface="DejaVu Sans"/>
-              </a:defRPr>
-            </a:lvl2pPr>
-            <a:lvl3pPr algn="l">
-              <a:buNone/>
-              <a:defRPr sz="1950" b="0">
-                <a:solidFill>
-                  <a:srgbClr val="4B526F"/>
-                </a:solidFill>
-                <a:latin typeface="DejaVu Sans"/>
-                <a:ea typeface="DejaVu Sans"/>
-                <a:cs typeface="DejaVu Sans"/>
-              </a:defRPr>
-            </a:lvl3pPr>
-            <a:lvl4pPr algn="l">
-              <a:buNone/>
-              <a:defRPr sz="1950" b="0">
-                <a:solidFill>
-                  <a:srgbClr val="4B526F"/>
-                </a:solidFill>
-                <a:latin typeface="DejaVu Sans"/>
-                <a:ea typeface="DejaVu Sans"/>
-                <a:cs typeface="DejaVu Sans"/>
-              </a:defRPr>
-            </a:lvl4pPr>
-            <a:lvl5pPr algn="l">
-              <a:buNone/>
-              <a:defRPr sz="1950" b="0">
-                <a:solidFill>
-                  <a:srgbClr val="4B526F"/>
-                </a:solidFill>
-                <a:latin typeface="DejaVu Sans"/>
-                <a:ea typeface="DejaVu Sans"/>
-                <a:cs typeface="DejaVu Sans"/>
-              </a:defRPr>
-            </a:lvl5pPr>
-            <a:lvl6pPr algn="l">
-              <a:buNone/>
-              <a:defRPr sz="1950" b="0">
-                <a:solidFill>
-                  <a:srgbClr val="4B526F"/>
-                </a:solidFill>
-                <a:latin typeface="DejaVu Sans"/>
-                <a:ea typeface="DejaVu Sans"/>
-                <a:cs typeface="DejaVu Sans"/>
-              </a:defRPr>
-            </a:lvl6pPr>
-            <a:lvl7pPr algn="l">
-              <a:buNone/>
-              <a:defRPr sz="1950" b="0">
-                <a:solidFill>
-                  <a:srgbClr val="4B526F"/>
-                </a:solidFill>
-                <a:latin typeface="DejaVu Sans"/>
-                <a:ea typeface="DejaVu Sans"/>
-                <a:cs typeface="DejaVu Sans"/>
-              </a:defRPr>
-            </a:lvl7pPr>
-            <a:lvl8pPr algn="l">
-              <a:buNone/>
-              <a:defRPr sz="1950" b="0">
-                <a:solidFill>
-                  <a:srgbClr val="4B526F"/>
-                </a:solidFill>
-                <a:latin typeface="DejaVu Sans"/>
-                <a:ea typeface="DejaVu Sans"/>
-                <a:cs typeface="DejaVu Sans"/>
-              </a:defRPr>
-            </a:lvl8pPr>
-            <a:lvl9pPr algn="l">
-              <a:buNone/>
-              <a:defRPr sz="1950" b="0">
-                <a:solidFill>
-                  <a:srgbClr val="4B526F"/>
-                </a:solidFill>
-                <a:latin typeface="DejaVu Sans"/>
-                <a:ea typeface="DejaVu Sans"/>
-                <a:cs typeface="DejaVu Sans"/>
-              </a:defRPr>
-            </a:lvl9pPr>
-          </a:lstStyle>
-          <a:p xmlns:a="http://schemas.openxmlformats.org/drawingml/2006/main">
+          <a:lstStyle/>
+          <a:p>
             <a:pPr algn="l">
-              <a:lnSpc>
-                <a:spcPct val="112000"/>
-              </a:lnSpc>
-              <a:buNone/>
-              <a:defRPr sz="1950" b="0">
-                <a:solidFill>
-                  <a:srgbClr val="4B526F"/>
-                </a:solidFill>
-                <a:latin typeface="DejaVu Sans"/>
-                <a:ea typeface="DejaVu Sans"/>
-                <a:cs typeface="DejaVu Sans"/>
+              <a:defRPr sz="1200" b="0">
+                <a:solidFill>
+                  <a:srgbClr val="10142B"/>
+                </a:solidFill>
+                <a:latin typeface="DejaVu Sans"/>
               </a:defRPr>
             </a:pPr>
             <a:r>
-              <a:rPr sz="1950" b="0">
-                <a:solidFill>
-                  <a:srgbClr val="4B526F"/>
-                </a:solidFill>
-                <a:latin typeface="DejaVu Sans"/>
-                <a:ea typeface="DejaVu Sans"/>
-                <a:cs typeface="DejaVu Sans"/>
-              </a:rPr>
-              <a:t>Enterprise application development</a:t>
-            </a:r>
-          </a:p>
-          <a:p xmlns:a="http://schemas.openxmlformats.org/drawingml/2006/main">
-            <a:pPr algn="l">
-              <a:lnSpc>
-                <a:spcPct val="112000"/>
-              </a:lnSpc>
-              <a:buNone/>
-              <a:defRPr sz="1950" b="0">
-                <a:solidFill>
-                  <a:srgbClr val="4B526F"/>
-                </a:solidFill>
-                <a:latin typeface="DejaVu Sans"/>
-                <a:ea typeface="DejaVu Sans"/>
-                <a:cs typeface="DejaVu Sans"/>
-              </a:defRPr>
-            </a:pPr>
-            <a:r>
-              <a:rPr sz="1950" b="0">
-                <a:solidFill>
-                  <a:srgbClr val="4B526F"/>
-                </a:solidFill>
-                <a:latin typeface="DejaVu Sans"/>
-                <a:ea typeface="DejaVu Sans"/>
-                <a:cs typeface="DejaVu Sans"/>
-              </a:rPr>
-              <a:t>and integration across banking,</a:t>
-            </a:r>
-          </a:p>
-          <a:p xmlns:a="http://schemas.openxmlformats.org/drawingml/2006/main">
-            <a:pPr algn="l">
-              <a:lnSpc>
-                <a:spcPct val="112000"/>
-              </a:lnSpc>
-              <a:buNone/>
-              <a:defRPr sz="1950" b="0">
-                <a:solidFill>
-                  <a:srgbClr val="4B526F"/>
-                </a:solidFill>
-                <a:latin typeface="DejaVu Sans"/>
-                <a:ea typeface="DejaVu Sans"/>
-                <a:cs typeface="DejaVu Sans"/>
-              </a:defRPr>
-            </a:pPr>
-            <a:r>
-              <a:rPr sz="1950" b="0">
-                <a:solidFill>
-                  <a:srgbClr val="4B526F"/>
-                </a:solidFill>
-                <a:latin typeface="DejaVu Sans"/>
-                <a:ea typeface="DejaVu Sans"/>
-                <a:cs typeface="DejaVu Sans"/>
-              </a:rPr>
-              <a:t>finance, insurance and e-commerce</a:t>
+              <a:t>Enterprise application development and integration across banking, finance, insurance and e-commerce</a:t>
             </a:r>
           </a:p>
         </p:txBody>
       </p:sp>
-      <p:sp>
+      <p:sp xmlns:a="http://schemas.openxmlformats.org/drawingml/2006/main">
         <p:nvSpPr>
-          <p:cNvPr id="7" name="founder-relevance">
-            <a:extLst xmlns:a="http://schemas.openxmlformats.org/drawingml/2006/main">
-              <a:ext uri="{FF2B5EF4-FFF2-40B4-BE49-F238E27FC236}">
-                <a16:creationId xmlns:a16="http://schemas.microsoft.com/office/drawing/2014/main" id="{8B6D8945-1AAB-4128-86F6-BA640F74E52C}"/>
-              </a:ext>
-            </a:extLst>
-          </p:cNvPr>
-          <p:cNvSpPr>
-            <a:spLocks xmlns:a="http://schemas.openxmlformats.org/drawingml/2006/main" noGrp="1"/>
-          </p:cNvSpPr>
+          <p:cNvPr id="19" name="TextBox 18"/>
+          <p:cNvSpPr txBox="1"/>
           <p:nvPr/>
         </p:nvSpPr>
         <p:spPr>
-          <a:xfrm xmlns:a="http://schemas.openxmlformats.org/drawingml/2006/main">
-            <a:off x="571500" y="4676775"/>
-            <a:ext cx="4476750" cy="1190625"/>
+          <a:xfrm>
+            <a:off x="777240" y="3931920"/>
+            <a:ext cx="3108960" cy="1188720"/>
           </a:xfrm>
-          <a:prstGeom xmlns:a="http://schemas.openxmlformats.org/drawingml/2006/main" prst="rect">
+          <a:prstGeom prst="rect">
             <a:avLst/>
           </a:prstGeom>
-          <a:noFill xmlns:a="http://schemas.openxmlformats.org/drawingml/2006/main"/>
-          <a:ln xmlns:a="http://schemas.openxmlformats.org/drawingml/2006/main" w="0">
-            <a:noFill/>
-            <a:prstDash val="solid"/>
-          </a:ln>
+          <a:noFill/>
         </p:spPr>
         <p:txBody>
-          <a:bodyPr xmlns:a="http://schemas.openxmlformats.org/drawingml/2006/main" wrap="square" lIns="0" tIns="0" rIns="0" bIns="0" anchor="t">
-            <a:noAutofit/>
+          <a:bodyPr wrap="square">
+            <a:spAutoFit/>
           </a:bodyPr>
-          <a:lstStyle xmlns:a="http://schemas.openxmlformats.org/drawingml/2006/main">
-            <a:defPPr algn="l">
-              <a:defRPr sz="1725" b="0">
-                <a:solidFill>
-                  <a:srgbClr val="4B526F"/>
-                </a:solidFill>
-                <a:latin typeface="DejaVu Sans"/>
-                <a:ea typeface="DejaVu Sans"/>
-                <a:cs typeface="DejaVu Sans"/>
-              </a:defRPr>
-            </a:defPPr>
-            <a:lvl1pPr algn="l">
-              <a:buNone/>
-              <a:defRPr sz="1725" b="0">
-                <a:solidFill>
-                  <a:srgbClr val="4B526F"/>
-                </a:solidFill>
-                <a:latin typeface="DejaVu Sans"/>
-                <a:ea typeface="DejaVu Sans"/>
-                <a:cs typeface="DejaVu Sans"/>
-              </a:defRPr>
-            </a:lvl1pPr>
-            <a:lvl2pPr algn="l">
-              <a:buNone/>
-              <a:defRPr sz="1725" b="0">
-                <a:solidFill>
-                  <a:srgbClr val="4B526F"/>
-                </a:solidFill>
-                <a:latin typeface="DejaVu Sans"/>
-                <a:ea typeface="DejaVu Sans"/>
-                <a:cs typeface="DejaVu Sans"/>
-              </a:defRPr>
-            </a:lvl2pPr>
-            <a:lvl3pPr algn="l">
-              <a:buNone/>
-              <a:defRPr sz="1725" b="0">
-                <a:solidFill>
-                  <a:srgbClr val="4B526F"/>
-                </a:solidFill>
-                <a:latin typeface="DejaVu Sans"/>
-                <a:ea typeface="DejaVu Sans"/>
-                <a:cs typeface="DejaVu Sans"/>
-              </a:defRPr>
-            </a:lvl3pPr>
-            <a:lvl4pPr algn="l">
-              <a:buNone/>
-              <a:defRPr sz="1725" b="0">
-                <a:solidFill>
-                  <a:srgbClr val="4B526F"/>
-                </a:solidFill>
-                <a:latin typeface="DejaVu Sans"/>
-                <a:ea typeface="DejaVu Sans"/>
-                <a:cs typeface="DejaVu Sans"/>
-              </a:defRPr>
-            </a:lvl4pPr>
-            <a:lvl5pPr algn="l">
-              <a:buNone/>
-              <a:defRPr sz="1725" b="0">
-                <a:solidFill>
-                  <a:srgbClr val="4B526F"/>
-                </a:solidFill>
-                <a:latin typeface="DejaVu Sans"/>
-                <a:ea typeface="DejaVu Sans"/>
-                <a:cs typeface="DejaVu Sans"/>
-              </a:defRPr>
-            </a:lvl5pPr>
-            <a:lvl6pPr algn="l">
-              <a:buNone/>
-              <a:defRPr sz="1725" b="0">
-                <a:solidFill>
-                  <a:srgbClr val="4B526F"/>
-                </a:solidFill>
-                <a:latin typeface="DejaVu Sans"/>
-                <a:ea typeface="DejaVu Sans"/>
-                <a:cs typeface="DejaVu Sans"/>
-              </a:defRPr>
-            </a:lvl6pPr>
-            <a:lvl7pPr algn="l">
-              <a:buNone/>
-              <a:defRPr sz="1725" b="0">
-                <a:solidFill>
-                  <a:srgbClr val="4B526F"/>
-                </a:solidFill>
-                <a:latin typeface="DejaVu Sans"/>
-                <a:ea typeface="DejaVu Sans"/>
-                <a:cs typeface="DejaVu Sans"/>
-              </a:defRPr>
-            </a:lvl7pPr>
-            <a:lvl8pPr algn="l">
-              <a:buNone/>
-              <a:defRPr sz="1725" b="0">
-                <a:solidFill>
-                  <a:srgbClr val="4B526F"/>
-                </a:solidFill>
-                <a:latin typeface="DejaVu Sans"/>
-                <a:ea typeface="DejaVu Sans"/>
-                <a:cs typeface="DejaVu Sans"/>
-              </a:defRPr>
-            </a:lvl8pPr>
-            <a:lvl9pPr algn="l">
-              <a:buNone/>
-              <a:defRPr sz="1725" b="0">
-                <a:solidFill>
-                  <a:srgbClr val="4B526F"/>
-                </a:solidFill>
-                <a:latin typeface="DejaVu Sans"/>
-                <a:ea typeface="DejaVu Sans"/>
-                <a:cs typeface="DejaVu Sans"/>
-              </a:defRPr>
-            </a:lvl9pPr>
-          </a:lstStyle>
-          <a:p xmlns:a="http://schemas.openxmlformats.org/drawingml/2006/main">
+          <a:lstStyle/>
+          <a:p>
             <a:pPr algn="l">
-              <a:lnSpc>
-                <a:spcPct val="112000"/>
-              </a:lnSpc>
-              <a:buNone/>
-              <a:defRPr sz="1725" b="0">
-                <a:solidFill>
-                  <a:srgbClr val="4B526F"/>
-                </a:solidFill>
-                <a:latin typeface="DejaVu Sans"/>
-                <a:ea typeface="DejaVu Sans"/>
-                <a:cs typeface="DejaVu Sans"/>
+              <a:defRPr sz="1150" b="0">
+                <a:solidFill>
+                  <a:srgbClr val="5A6578"/>
+                </a:solidFill>
+                <a:latin typeface="DejaVu Sans"/>
               </a:defRPr>
             </a:pPr>
             <a:r>
-              <a:rPr sz="1725" b="0">
-                <a:solidFill>
-                  <a:srgbClr val="4B526F"/>
-                </a:solidFill>
-                <a:latin typeface="DejaVu Sans"/>
-                <a:ea typeface="DejaVu Sans"/>
-                <a:cs typeface="DejaVu Sans"/>
-              </a:rPr>
-              <a:t>Payments and financial workflows</a:t>
+              <a:t>• Payments &amp; Workflows</a:t>
             </a:r>
           </a:p>
-          <a:p xmlns:a="http://schemas.openxmlformats.org/drawingml/2006/main">
+          <a:p>
             <a:pPr algn="l">
-              <a:lnSpc>
-                <a:spcPct val="112000"/>
-              </a:lnSpc>
-              <a:buNone/>
-              <a:defRPr sz="1725" b="0">
-                <a:solidFill>
-                  <a:srgbClr val="4B526F"/>
-                </a:solidFill>
-                <a:latin typeface="DejaVu Sans"/>
-                <a:ea typeface="DejaVu Sans"/>
-                <a:cs typeface="DejaVu Sans"/>
+              <a:defRPr sz="1150" b="0">
+                <a:solidFill>
+                  <a:srgbClr val="5A6578"/>
+                </a:solidFill>
+                <a:latin typeface="DejaVu Sans"/>
               </a:defRPr>
             </a:pPr>
             <a:r>
-              <a:rPr sz="1725" b="0">
-                <a:solidFill>
-                  <a:srgbClr val="4B526F"/>
-                </a:solidFill>
-                <a:latin typeface="DejaVu Sans"/>
-                <a:ea typeface="DejaVu Sans"/>
-                <a:cs typeface="DejaVu Sans"/>
-              </a:rPr>
-              <a:t>Java, Python, React and data systems</a:t>
+              <a:t>• Java · Python · React</a:t>
             </a:r>
           </a:p>
-          <a:p xmlns:a="http://schemas.openxmlformats.org/drawingml/2006/main">
+          <a:p>
             <a:pPr algn="l">
-              <a:lnSpc>
-                <a:spcPct val="112000"/>
-              </a:lnSpc>
-              <a:buNone/>
-              <a:defRPr sz="1725" b="0">
-                <a:solidFill>
-                  <a:srgbClr val="4B526F"/>
-                </a:solidFill>
-                <a:latin typeface="DejaVu Sans"/>
-                <a:ea typeface="DejaVu Sans"/>
-                <a:cs typeface="DejaVu Sans"/>
+              <a:defRPr sz="1150" b="0">
+                <a:solidFill>
+                  <a:srgbClr val="5A6578"/>
+                </a:solidFill>
+                <a:latin typeface="DejaVu Sans"/>
               </a:defRPr>
             </a:pPr>
             <a:r>
-              <a:rPr sz="1725" b="0">
-                <a:solidFill>
-                  <a:srgbClr val="4B526F"/>
-                </a:solidFill>
-                <a:latin typeface="DejaVu Sans"/>
-                <a:ea typeface="DejaVu Sans"/>
-                <a:cs typeface="DejaVu Sans"/>
-              </a:rPr>
-              <a:t>B.C.-based product development</a:t>
+              <a:t>• B.C.-based development</a:t>
             </a:r>
           </a:p>
         </p:txBody>
       </p:sp>
-      <p:sp>
+      <p:sp xmlns:a="http://schemas.openxmlformats.org/drawingml/2006/main">
         <p:nvSpPr>
-          <p:cNvPr id="8" name="roadmap-time-0">
-            <a:extLst xmlns:a="http://schemas.openxmlformats.org/drawingml/2006/main">
-              <a:ext uri="{FF2B5EF4-FFF2-40B4-BE49-F238E27FC236}">
-                <a16:creationId xmlns:a16="http://schemas.microsoft.com/office/drawing/2014/main" id="{196FF61A-72DB-4A9E-B7F7-1036A8469930}"/>
-              </a:ext>
-            </a:extLst>
-          </p:cNvPr>
-          <p:cNvSpPr>
-            <a:spLocks xmlns:a="http://schemas.openxmlformats.org/drawingml/2006/main" noGrp="1"/>
-          </p:cNvSpPr>
+          <p:cNvPr id="20" name="TextBox 19"/>
+          <p:cNvSpPr txBox="1"/>
           <p:nvPr/>
         </p:nvSpPr>
         <p:spPr>
-          <a:xfrm xmlns:a="http://schemas.openxmlformats.org/drawingml/2006/main">
-            <a:off x="6286500" y="2057400"/>
-            <a:ext cx="5286375" cy="352425"/>
+          <a:xfrm>
+            <a:off x="777240" y="5532120"/>
+            <a:ext cx="3108960" cy="457200"/>
           </a:xfrm>
-          <a:prstGeom xmlns:a="http://schemas.openxmlformats.org/drawingml/2006/main" prst="rect">
+          <a:prstGeom prst="rect">
             <a:avLst/>
           </a:prstGeom>
-          <a:noFill xmlns:a="http://schemas.openxmlformats.org/drawingml/2006/main"/>
-          <a:ln xmlns:a="http://schemas.openxmlformats.org/drawingml/2006/main" w="0">
-            <a:noFill/>
-            <a:prstDash val="solid"/>
-          </a:ln>
+          <a:noFill/>
         </p:spPr>
         <p:txBody>
-          <a:bodyPr xmlns:a="http://schemas.openxmlformats.org/drawingml/2006/main" wrap="square" lIns="0" tIns="0" rIns="0" bIns="0" anchor="t">
-            <a:noAutofit/>
+          <a:bodyPr wrap="none">
+            <a:spAutoFit/>
           </a:bodyPr>
-          <a:lstStyle xmlns:a="http://schemas.openxmlformats.org/drawingml/2006/main">
-            <a:defPPr algn="l">
-              <a:defRPr sz="1950" b="1">
-                <a:solidFill>
-                  <a:srgbClr val="6847F5"/>
-                </a:solidFill>
-                <a:latin typeface="DejaVu Sans"/>
-                <a:ea typeface="DejaVu Sans"/>
-                <a:cs typeface="DejaVu Sans"/>
-              </a:defRPr>
-            </a:defPPr>
-            <a:lvl1pPr algn="l">
-              <a:buNone/>
-              <a:defRPr sz="1950" b="1">
-                <a:solidFill>
-                  <a:srgbClr val="6847F5"/>
-                </a:solidFill>
-                <a:latin typeface="DejaVu Sans"/>
-                <a:ea typeface="DejaVu Sans"/>
-                <a:cs typeface="DejaVu Sans"/>
-              </a:defRPr>
-            </a:lvl1pPr>
-            <a:lvl2pPr algn="l">
-              <a:buNone/>
-              <a:defRPr sz="1950" b="1">
-                <a:solidFill>
-                  <a:srgbClr val="6847F5"/>
-                </a:solidFill>
-                <a:latin typeface="DejaVu Sans"/>
-                <a:ea typeface="DejaVu Sans"/>
-                <a:cs typeface="DejaVu Sans"/>
-              </a:defRPr>
-            </a:lvl2pPr>
-            <a:lvl3pPr algn="l">
-              <a:buNone/>
-              <a:defRPr sz="1950" b="1">
-                <a:solidFill>
-                  <a:srgbClr val="6847F5"/>
-                </a:solidFill>
-                <a:latin typeface="DejaVu Sans"/>
-                <a:ea typeface="DejaVu Sans"/>
-                <a:cs typeface="DejaVu Sans"/>
-              </a:defRPr>
-            </a:lvl3pPr>
-            <a:lvl4pPr algn="l">
-              <a:buNone/>
-              <a:defRPr sz="1950" b="1">
-                <a:solidFill>
-                  <a:srgbClr val="6847F5"/>
-                </a:solidFill>
-                <a:latin typeface="DejaVu Sans"/>
-                <a:ea typeface="DejaVu Sans"/>
-                <a:cs typeface="DejaVu Sans"/>
-              </a:defRPr>
-            </a:lvl4pPr>
-            <a:lvl5pPr algn="l">
-              <a:buNone/>
-              <a:defRPr sz="1950" b="1">
-                <a:solidFill>
-                  <a:srgbClr val="6847F5"/>
-                </a:solidFill>
-                <a:latin typeface="DejaVu Sans"/>
-                <a:ea typeface="DejaVu Sans"/>
-                <a:cs typeface="DejaVu Sans"/>
-              </a:defRPr>
-            </a:lvl5pPr>
-            <a:lvl6pPr algn="l">
-              <a:buNone/>
-              <a:defRPr sz="1950" b="1">
-                <a:solidFill>
-                  <a:srgbClr val="6847F5"/>
-                </a:solidFill>
-                <a:latin typeface="DejaVu Sans"/>
-                <a:ea typeface="DejaVu Sans"/>
-                <a:cs typeface="DejaVu Sans"/>
-              </a:defRPr>
-            </a:lvl6pPr>
-            <a:lvl7pPr algn="l">
-              <a:buNone/>
-              <a:defRPr sz="1950" b="1">
-                <a:solidFill>
-                  <a:srgbClr val="6847F5"/>
-                </a:solidFill>
-                <a:latin typeface="DejaVu Sans"/>
-                <a:ea typeface="DejaVu Sans"/>
-                <a:cs typeface="DejaVu Sans"/>
-              </a:defRPr>
-            </a:lvl7pPr>
-            <a:lvl8pPr algn="l">
-              <a:buNone/>
-              <a:defRPr sz="1950" b="1">
-                <a:solidFill>
-                  <a:srgbClr val="6847F5"/>
-                </a:solidFill>
-                <a:latin typeface="DejaVu Sans"/>
-                <a:ea typeface="DejaVu Sans"/>
-                <a:cs typeface="DejaVu Sans"/>
-              </a:defRPr>
-            </a:lvl8pPr>
-            <a:lvl9pPr algn="l">
-              <a:buNone/>
-              <a:defRPr sz="1950" b="1">
-                <a:solidFill>
-                  <a:srgbClr val="6847F5"/>
-                </a:solidFill>
-                <a:latin typeface="DejaVu Sans"/>
-                <a:ea typeface="DejaVu Sans"/>
-                <a:cs typeface="DejaVu Sans"/>
-              </a:defRPr>
-            </a:lvl9pPr>
-          </a:lstStyle>
-          <a:p xmlns:a="http://schemas.openxmlformats.org/drawingml/2006/main">
+          <a:lstStyle/>
+          <a:p>
             <a:pPr algn="l">
-              <a:lnSpc>
-                <a:spcPct val="112000"/>
-              </a:lnSpc>
-              <a:buNone/>
-              <a:defRPr sz="1950" b="1">
-                <a:solidFill>
-                  <a:srgbClr val="6847F5"/>
-                </a:solidFill>
-                <a:latin typeface="DejaVu Sans"/>
-                <a:ea typeface="DejaVu Sans"/>
-                <a:cs typeface="DejaVu Sans"/>
+              <a:defRPr sz="1150" b="1">
+                <a:solidFill>
+                  <a:srgbClr val="6C5CE7"/>
+                </a:solidFill>
+                <a:latin typeface="DejaVu Sans"/>
               </a:defRPr>
             </a:pPr>
             <a:r>
-              <a:rPr sz="1950" b="1">
-                <a:solidFill>
-                  <a:srgbClr val="6847F5"/>
-                </a:solidFill>
-                <a:latin typeface="DejaVu Sans"/>
-                <a:ea typeface="DejaVu Sans"/>
-                <a:cs typeface="DejaVu Sans"/>
-              </a:rPr>
-              <a:t>Months 1–6</a:t>
+              <a:t>Contact: juhe.terence@gmail.com</a:t>
             </a:r>
           </a:p>
         </p:txBody>
       </p:sp>
-      <p:sp>
+      <p:sp xmlns:a="http://schemas.openxmlformats.org/drawingml/2006/main">
         <p:nvSpPr>
-          <p:cNvPr id="9" name="roadmap-milestone-0">
-            <a:extLst xmlns:a="http://schemas.openxmlformats.org/drawingml/2006/main">
-              <a:ext uri="{FF2B5EF4-FFF2-40B4-BE49-F238E27FC236}">
-                <a16:creationId xmlns:a16="http://schemas.microsoft.com/office/drawing/2014/main" id="{009E0BAC-06D8-442C-A826-D018B4B60791}"/>
-              </a:ext>
-            </a:extLst>
-          </p:cNvPr>
-          <p:cNvSpPr>
-            <a:spLocks xmlns:a="http://schemas.openxmlformats.org/drawingml/2006/main" noGrp="1"/>
-          </p:cNvSpPr>
+          <p:cNvPr id="21" name="Rectangle 20"/>
+          <p:cNvSpPr/>
           <p:nvPr/>
         </p:nvSpPr>
         <p:spPr>
-          <a:xfrm xmlns:a="http://schemas.openxmlformats.org/drawingml/2006/main">
-            <a:off x="6286500" y="2505075"/>
-            <a:ext cx="5286375" cy="733425"/>
+          <a:xfrm>
+            <a:off x="4297680" y="1874519"/>
+            <a:ext cx="4069080" cy="1280160"/>
           </a:xfrm>
-          <a:prstGeom xmlns:a="http://schemas.openxmlformats.org/drawingml/2006/main" prst="rect">
+          <a:prstGeom prst="rect">
             <a:avLst/>
           </a:prstGeom>
-          <a:noFill xmlns:a="http://schemas.openxmlformats.org/drawingml/2006/main"/>
-          <a:ln xmlns:a="http://schemas.openxmlformats.org/drawingml/2006/main" w="0">
-            <a:noFill/>
-            <a:prstDash val="solid"/>
+          <a:solidFill>
+            <a:srgbClr val="FFFFFF"/>
+          </a:solidFill>
+          <a:ln w="12700">
+            <a:solidFill>
+              <a:srgbClr val="DCE1EE"/>
+            </a:solidFill>
           </a:ln>
         </p:spPr>
+        <p:style>
+          <a:lnRef idx="1">
+            <a:schemeClr val="accent1"/>
+          </a:lnRef>
+          <a:fillRef idx="3">
+            <a:schemeClr val="accent1"/>
+          </a:fillRef>
+          <a:effectRef idx="2">
+            <a:schemeClr val="accent1"/>
+          </a:effectRef>
+          <a:fontRef idx="minor">
+            <a:schemeClr val="lt1"/>
+          </a:fontRef>
+        </p:style>
         <p:txBody>
-          <a:bodyPr xmlns:a="http://schemas.openxmlformats.org/drawingml/2006/main" wrap="square" lIns="0" tIns="0" rIns="0" bIns="0" anchor="t">
-            <a:noAutofit/>
+          <a:bodyPr rtlCol="0" anchor="ctr"/>
+          <a:lstStyle/>
+          <a:p>
+            <a:pPr algn="ctr"/>
+          </a:p>
+        </p:txBody>
+      </p:sp>
+      <p:sp xmlns:a="http://schemas.openxmlformats.org/drawingml/2006/main">
+        <p:nvSpPr>
+          <p:cNvPr id="22" name="Rectangle 21"/>
+          <p:cNvSpPr/>
+          <p:nvPr/>
+        </p:nvSpPr>
+        <p:spPr>
+          <a:xfrm>
+            <a:off x="4297680" y="1874519"/>
+            <a:ext cx="73152" cy="1280160"/>
+          </a:xfrm>
+          <a:prstGeom prst="rect">
+            <a:avLst/>
+          </a:prstGeom>
+          <a:solidFill>
+            <a:srgbClr val="6C5CE7"/>
+          </a:solidFill>
+          <a:ln>
+            <a:noFill/>
+          </a:ln>
+        </p:spPr>
+        <p:style>
+          <a:lnRef idx="1">
+            <a:schemeClr val="accent1"/>
+          </a:lnRef>
+          <a:fillRef idx="3">
+            <a:schemeClr val="accent1"/>
+          </a:fillRef>
+          <a:effectRef idx="2">
+            <a:schemeClr val="accent1"/>
+          </a:effectRef>
+          <a:fontRef idx="minor">
+            <a:schemeClr val="lt1"/>
+          </a:fontRef>
+        </p:style>
+        <p:txBody>
+          <a:bodyPr rtlCol="0" anchor="ctr"/>
+          <a:lstStyle/>
+          <a:p>
+            <a:pPr algn="ctr"/>
+          </a:p>
+        </p:txBody>
+      </p:sp>
+      <p:sp xmlns:a="http://schemas.openxmlformats.org/drawingml/2006/main">
+        <p:nvSpPr>
+          <p:cNvPr id="23" name="TextBox 22"/>
+          <p:cNvSpPr txBox="1"/>
+          <p:nvPr/>
+        </p:nvSpPr>
+        <p:spPr>
+          <a:xfrm>
+            <a:off x="4526280" y="1984247"/>
+            <a:ext cx="3703320" cy="1051560"/>
+          </a:xfrm>
+          <a:prstGeom prst="rect">
+            <a:avLst/>
+          </a:prstGeom>
+          <a:noFill/>
+        </p:spPr>
+        <p:txBody>
+          <a:bodyPr wrap="square">
+            <a:spAutoFit/>
           </a:bodyPr>
-          <a:lstStyle xmlns:a="http://schemas.openxmlformats.org/drawingml/2006/main">
-            <a:defPPr algn="l">
-              <a:defRPr sz="1800" b="0">
-                <a:solidFill>
-                  <a:srgbClr val="4B526F"/>
-                </a:solidFill>
-                <a:latin typeface="DejaVu Sans"/>
-                <a:ea typeface="DejaVu Sans"/>
-                <a:cs typeface="DejaVu Sans"/>
-              </a:defRPr>
-            </a:defPPr>
-            <a:lvl1pPr algn="l">
-              <a:buNone/>
-              <a:defRPr sz="1800" b="0">
-                <a:solidFill>
-                  <a:srgbClr val="4B526F"/>
-                </a:solidFill>
-                <a:latin typeface="DejaVu Sans"/>
-                <a:ea typeface="DejaVu Sans"/>
-                <a:cs typeface="DejaVu Sans"/>
-              </a:defRPr>
-            </a:lvl1pPr>
-            <a:lvl2pPr algn="l">
-              <a:buNone/>
-              <a:defRPr sz="1800" b="0">
-                <a:solidFill>
-                  <a:srgbClr val="4B526F"/>
-                </a:solidFill>
-                <a:latin typeface="DejaVu Sans"/>
-                <a:ea typeface="DejaVu Sans"/>
-                <a:cs typeface="DejaVu Sans"/>
-              </a:defRPr>
-            </a:lvl2pPr>
-            <a:lvl3pPr algn="l">
-              <a:buNone/>
-              <a:defRPr sz="1800" b="0">
-                <a:solidFill>
-                  <a:srgbClr val="4B526F"/>
-                </a:solidFill>
-                <a:latin typeface="DejaVu Sans"/>
-                <a:ea typeface="DejaVu Sans"/>
-                <a:cs typeface="DejaVu Sans"/>
-              </a:defRPr>
-            </a:lvl3pPr>
-            <a:lvl4pPr algn="l">
-              <a:buNone/>
-              <a:defRPr sz="1800" b="0">
-                <a:solidFill>
-                  <a:srgbClr val="4B526F"/>
-                </a:solidFill>
-                <a:latin typeface="DejaVu Sans"/>
-                <a:ea typeface="DejaVu Sans"/>
-                <a:cs typeface="DejaVu Sans"/>
-              </a:defRPr>
-            </a:lvl4pPr>
-            <a:lvl5pPr algn="l">
-              <a:buNone/>
-              <a:defRPr sz="1800" b="0">
-                <a:solidFill>
-                  <a:srgbClr val="4B526F"/>
-                </a:solidFill>
-                <a:latin typeface="DejaVu Sans"/>
-                <a:ea typeface="DejaVu Sans"/>
-                <a:cs typeface="DejaVu Sans"/>
-              </a:defRPr>
-            </a:lvl5pPr>
-            <a:lvl6pPr algn="l">
-              <a:buNone/>
-              <a:defRPr sz="1800" b="0">
-                <a:solidFill>
-                  <a:srgbClr val="4B526F"/>
-                </a:solidFill>
-                <a:latin typeface="DejaVu Sans"/>
-                <a:ea typeface="DejaVu Sans"/>
-                <a:cs typeface="DejaVu Sans"/>
-              </a:defRPr>
-            </a:lvl6pPr>
-            <a:lvl7pPr algn="l">
-              <a:buNone/>
-              <a:defRPr sz="1800" b="0">
-                <a:solidFill>
-                  <a:srgbClr val="4B526F"/>
-                </a:solidFill>
-                <a:latin typeface="DejaVu Sans"/>
-                <a:ea typeface="DejaVu Sans"/>
-                <a:cs typeface="DejaVu Sans"/>
-              </a:defRPr>
-            </a:lvl7pPr>
-            <a:lvl8pPr algn="l">
-              <a:buNone/>
-              <a:defRPr sz="1800" b="0">
-                <a:solidFill>
-                  <a:srgbClr val="4B526F"/>
-                </a:solidFill>
-                <a:latin typeface="DejaVu Sans"/>
-                <a:ea typeface="DejaVu Sans"/>
-                <a:cs typeface="DejaVu Sans"/>
-              </a:defRPr>
-            </a:lvl8pPr>
-            <a:lvl9pPr algn="l">
-              <a:buNone/>
-              <a:defRPr sz="1800" b="0">
-                <a:solidFill>
-                  <a:srgbClr val="4B526F"/>
-                </a:solidFill>
-                <a:latin typeface="DejaVu Sans"/>
-                <a:ea typeface="DejaVu Sans"/>
-                <a:cs typeface="DejaVu Sans"/>
-              </a:defRPr>
-            </a:lvl9pPr>
-          </a:lstStyle>
-          <a:p xmlns:a="http://schemas.openxmlformats.org/drawingml/2006/main">
+          <a:lstStyle/>
+          <a:p>
             <a:pPr algn="l">
-              <a:lnSpc>
-                <a:spcPct val="112000"/>
-              </a:lnSpc>
-              <a:buNone/>
-              <a:defRPr sz="1800" b="0">
-                <a:solidFill>
-                  <a:srgbClr val="4B526F"/>
-                </a:solidFill>
-                <a:latin typeface="DejaVu Sans"/>
-                <a:ea typeface="DejaVu Sans"/>
-                <a:cs typeface="DejaVu Sans"/>
+              <a:defRPr sz="1400" b="1">
+                <a:solidFill>
+                  <a:srgbClr val="6C5CE7"/>
+                </a:solidFill>
+                <a:latin typeface="DejaVu Sans"/>
               </a:defRPr>
             </a:pPr>
             <a:r>
-              <a:rPr sz="1800" b="0">
-                <a:solidFill>
-                  <a:srgbClr val="4B526F"/>
-                </a:solidFill>
-                <a:latin typeface="DejaVu Sans"/>
-                <a:ea typeface="DejaVu Sans"/>
-                <a:cs typeface="DejaVu Sans"/>
-              </a:rPr>
-              <a:t>Quotation extraction and review</a:t>
+              <a:t>Months 1–6</a:t>
             </a:r>
           </a:p>
-          <a:p xmlns:a="http://schemas.openxmlformats.org/drawingml/2006/main">
+          <a:p>
             <a:pPr algn="l">
-              <a:lnSpc>
-                <a:spcPct val="112000"/>
-              </a:lnSpc>
-              <a:buNone/>
-              <a:defRPr sz="1800" b="0">
-                <a:solidFill>
-                  <a:srgbClr val="4B526F"/>
-                </a:solidFill>
-                <a:latin typeface="DejaVu Sans"/>
-                <a:ea typeface="DejaVu Sans"/>
-                <a:cs typeface="DejaVu Sans"/>
+              <a:defRPr sz="1100" b="0">
+                <a:solidFill>
+                  <a:srgbClr val="5A6578"/>
+                </a:solidFill>
+                <a:latin typeface="DejaVu Sans"/>
               </a:defRPr>
             </a:pPr>
             <a:r>
-              <a:rPr sz="1800" b="0">
-                <a:solidFill>
-                  <a:srgbClr val="4B526F"/>
-                </a:solidFill>
-                <a:latin typeface="DejaVu Sans"/>
-                <a:ea typeface="DejaVu Sans"/>
-                <a:cs typeface="DejaVu Sans"/>
-              </a:rPr>
-              <a:t>Reproducible cost comparisons</a:t>
+              <a:t>Quotation extraction and review · Reproducible cost comparisons</a:t>
             </a:r>
           </a:p>
         </p:txBody>
       </p:sp>
-      <p:sp>
+      <p:sp xmlns:a="http://schemas.openxmlformats.org/drawingml/2006/main">
         <p:nvSpPr>
-          <p:cNvPr id="10" name="roadmap-time-1">
-            <a:extLst xmlns:a="http://schemas.openxmlformats.org/drawingml/2006/main">
-              <a:ext uri="{FF2B5EF4-FFF2-40B4-BE49-F238E27FC236}">
-                <a16:creationId xmlns:a16="http://schemas.microsoft.com/office/drawing/2014/main" id="{821A2242-13A1-4DA5-B634-AF4E095710FD}"/>
-              </a:ext>
-            </a:extLst>
-          </p:cNvPr>
-          <p:cNvSpPr>
-            <a:spLocks xmlns:a="http://schemas.openxmlformats.org/drawingml/2006/main" noGrp="1"/>
-          </p:cNvSpPr>
+          <p:cNvPr id="24" name="Rectangle 23"/>
+          <p:cNvSpPr/>
           <p:nvPr/>
         </p:nvSpPr>
         <p:spPr>
-          <a:xfrm xmlns:a="http://schemas.openxmlformats.org/drawingml/2006/main">
-            <a:off x="6286500" y="3324225"/>
-            <a:ext cx="5286375" cy="352425"/>
+          <a:xfrm>
+            <a:off x="4297680" y="3401568"/>
+            <a:ext cx="4069080" cy="1280160"/>
           </a:xfrm>
-          <a:prstGeom xmlns:a="http://schemas.openxmlformats.org/drawingml/2006/main" prst="rect">
+          <a:prstGeom prst="rect">
             <a:avLst/>
           </a:prstGeom>
-          <a:noFill xmlns:a="http://schemas.openxmlformats.org/drawingml/2006/main"/>
-          <a:ln xmlns:a="http://schemas.openxmlformats.org/drawingml/2006/main" w="0">
-            <a:noFill/>
-            <a:prstDash val="solid"/>
+          <a:solidFill>
+            <a:srgbClr val="FFFFFF"/>
+          </a:solidFill>
+          <a:ln w="12700">
+            <a:solidFill>
+              <a:srgbClr val="DCE1EE"/>
+            </a:solidFill>
           </a:ln>
         </p:spPr>
+        <p:style>
+          <a:lnRef idx="1">
+            <a:schemeClr val="accent1"/>
+          </a:lnRef>
+          <a:fillRef idx="3">
+            <a:schemeClr val="accent1"/>
+          </a:fillRef>
+          <a:effectRef idx="2">
+            <a:schemeClr val="accent1"/>
+          </a:effectRef>
+          <a:fontRef idx="minor">
+            <a:schemeClr val="lt1"/>
+          </a:fontRef>
+        </p:style>
         <p:txBody>
-          <a:bodyPr xmlns:a="http://schemas.openxmlformats.org/drawingml/2006/main" wrap="square" lIns="0" tIns="0" rIns="0" bIns="0" anchor="t">
-            <a:noAutofit/>
+          <a:bodyPr rtlCol="0" anchor="ctr"/>
+          <a:lstStyle/>
+          <a:p>
+            <a:pPr algn="ctr"/>
+          </a:p>
+        </p:txBody>
+      </p:sp>
+      <p:sp xmlns:a="http://schemas.openxmlformats.org/drawingml/2006/main">
+        <p:nvSpPr>
+          <p:cNvPr id="25" name="Rectangle 24"/>
+          <p:cNvSpPr/>
+          <p:nvPr/>
+        </p:nvSpPr>
+        <p:spPr>
+          <a:xfrm>
+            <a:off x="4297680" y="3401568"/>
+            <a:ext cx="73152" cy="1280160"/>
+          </a:xfrm>
+          <a:prstGeom prst="rect">
+            <a:avLst/>
+          </a:prstGeom>
+          <a:solidFill>
+            <a:srgbClr val="6C5CE7"/>
+          </a:solidFill>
+          <a:ln>
+            <a:noFill/>
+          </a:ln>
+        </p:spPr>
+        <p:style>
+          <a:lnRef idx="1">
+            <a:schemeClr val="accent1"/>
+          </a:lnRef>
+          <a:fillRef idx="3">
+            <a:schemeClr val="accent1"/>
+          </a:fillRef>
+          <a:effectRef idx="2">
+            <a:schemeClr val="accent1"/>
+          </a:effectRef>
+          <a:fontRef idx="minor">
+            <a:schemeClr val="lt1"/>
+          </a:fontRef>
+        </p:style>
+        <p:txBody>
+          <a:bodyPr rtlCol="0" anchor="ctr"/>
+          <a:lstStyle/>
+          <a:p>
+            <a:pPr algn="ctr"/>
+          </a:p>
+        </p:txBody>
+      </p:sp>
+      <p:sp xmlns:a="http://schemas.openxmlformats.org/drawingml/2006/main">
+        <p:nvSpPr>
+          <p:cNvPr id="26" name="TextBox 25"/>
+          <p:cNvSpPr txBox="1"/>
+          <p:nvPr/>
+        </p:nvSpPr>
+        <p:spPr>
+          <a:xfrm>
+            <a:off x="4526280" y="3511296"/>
+            <a:ext cx="3703320" cy="1051560"/>
+          </a:xfrm>
+          <a:prstGeom prst="rect">
+            <a:avLst/>
+          </a:prstGeom>
+          <a:noFill/>
+        </p:spPr>
+        <p:txBody>
+          <a:bodyPr wrap="square">
+            <a:spAutoFit/>
           </a:bodyPr>
-          <a:lstStyle xmlns:a="http://schemas.openxmlformats.org/drawingml/2006/main">
-            <a:defPPr algn="l">
-              <a:defRPr sz="1950" b="1">
-                <a:solidFill>
-                  <a:srgbClr val="6847F5"/>
-                </a:solidFill>
-                <a:latin typeface="DejaVu Sans"/>
-                <a:ea typeface="DejaVu Sans"/>
-                <a:cs typeface="DejaVu Sans"/>
-              </a:defRPr>
-            </a:defPPr>
-            <a:lvl1pPr algn="l">
-              <a:buNone/>
-              <a:defRPr sz="1950" b="1">
-                <a:solidFill>
-                  <a:srgbClr val="6847F5"/>
-                </a:solidFill>
-                <a:latin typeface="DejaVu Sans"/>
-                <a:ea typeface="DejaVu Sans"/>
-                <a:cs typeface="DejaVu Sans"/>
-              </a:defRPr>
-            </a:lvl1pPr>
-            <a:lvl2pPr algn="l">
-              <a:buNone/>
-              <a:defRPr sz="1950" b="1">
-                <a:solidFill>
-                  <a:srgbClr val="6847F5"/>
-                </a:solidFill>
-                <a:latin typeface="DejaVu Sans"/>
-                <a:ea typeface="DejaVu Sans"/>
-                <a:cs typeface="DejaVu Sans"/>
-              </a:defRPr>
-            </a:lvl2pPr>
-            <a:lvl3pPr algn="l">
-              <a:buNone/>
-              <a:defRPr sz="1950" b="1">
-                <a:solidFill>
-                  <a:srgbClr val="6847F5"/>
-                </a:solidFill>
-                <a:latin typeface="DejaVu Sans"/>
-                <a:ea typeface="DejaVu Sans"/>
-                <a:cs typeface="DejaVu Sans"/>
-              </a:defRPr>
-            </a:lvl3pPr>
-            <a:lvl4pPr algn="l">
-              <a:buNone/>
-              <a:defRPr sz="1950" b="1">
-                <a:solidFill>
-                  <a:srgbClr val="6847F5"/>
-                </a:solidFill>
-                <a:latin typeface="DejaVu Sans"/>
-                <a:ea typeface="DejaVu Sans"/>
-                <a:cs typeface="DejaVu Sans"/>
-              </a:defRPr>
-            </a:lvl4pPr>
-            <a:lvl5pPr algn="l">
-              <a:buNone/>
-              <a:defRPr sz="1950" b="1">
-                <a:solidFill>
-                  <a:srgbClr val="6847F5"/>
-                </a:solidFill>
-                <a:latin typeface="DejaVu Sans"/>
-                <a:ea typeface="DejaVu Sans"/>
-                <a:cs typeface="DejaVu Sans"/>
-              </a:defRPr>
-            </a:lvl5pPr>
-            <a:lvl6pPr algn="l">
-              <a:buNone/>
-              <a:defRPr sz="1950" b="1">
-                <a:solidFill>
-                  <a:srgbClr val="6847F5"/>
-                </a:solidFill>
-                <a:latin typeface="DejaVu Sans"/>
-                <a:ea typeface="DejaVu Sans"/>
-                <a:cs typeface="DejaVu Sans"/>
-              </a:defRPr>
-            </a:lvl6pPr>
-            <a:lvl7pPr algn="l">
-              <a:buNone/>
-              <a:defRPr sz="1950" b="1">
-                <a:solidFill>
-                  <a:srgbClr val="6847F5"/>
-                </a:solidFill>
-                <a:latin typeface="DejaVu Sans"/>
-                <a:ea typeface="DejaVu Sans"/>
-                <a:cs typeface="DejaVu Sans"/>
-              </a:defRPr>
-            </a:lvl7pPr>
-            <a:lvl8pPr algn="l">
-              <a:buNone/>
-              <a:defRPr sz="1950" b="1">
-                <a:solidFill>
-                  <a:srgbClr val="6847F5"/>
-                </a:solidFill>
-                <a:latin typeface="DejaVu Sans"/>
-                <a:ea typeface="DejaVu Sans"/>
-                <a:cs typeface="DejaVu Sans"/>
-              </a:defRPr>
-            </a:lvl8pPr>
-            <a:lvl9pPr algn="l">
-              <a:buNone/>
-              <a:defRPr sz="1950" b="1">
-                <a:solidFill>
-                  <a:srgbClr val="6847F5"/>
-                </a:solidFill>
-                <a:latin typeface="DejaVu Sans"/>
-                <a:ea typeface="DejaVu Sans"/>
-                <a:cs typeface="DejaVu Sans"/>
-              </a:defRPr>
-            </a:lvl9pPr>
-          </a:lstStyle>
-          <a:p xmlns:a="http://schemas.openxmlformats.org/drawingml/2006/main">
+          <a:lstStyle/>
+          <a:p>
             <a:pPr algn="l">
-              <a:lnSpc>
-                <a:spcPct val="112000"/>
-              </a:lnSpc>
-              <a:buNone/>
-              <a:defRPr sz="1950" b="1">
-                <a:solidFill>
-                  <a:srgbClr val="6847F5"/>
-                </a:solidFill>
-                <a:latin typeface="DejaVu Sans"/>
-                <a:ea typeface="DejaVu Sans"/>
-                <a:cs typeface="DejaVu Sans"/>
+              <a:defRPr sz="1400" b="1">
+                <a:solidFill>
+                  <a:srgbClr val="6C5CE7"/>
+                </a:solidFill>
+                <a:latin typeface="DejaVu Sans"/>
               </a:defRPr>
             </a:pPr>
             <a:r>
-              <a:rPr sz="1950" b="1">
-                <a:solidFill>
-                  <a:srgbClr val="6847F5"/>
-                </a:solidFill>
-                <a:latin typeface="DejaVu Sans"/>
-                <a:ea typeface="DejaVu Sans"/>
-                <a:cs typeface="DejaVu Sans"/>
-              </a:rPr>
               <a:t>Months 7–12</a:t>
+            </a:r>
+          </a:p>
+          <a:p>
+            <a:pPr algn="l">
+              <a:defRPr sz="1100" b="0">
+                <a:solidFill>
+                  <a:srgbClr val="5A6578"/>
+                </a:solidFill>
+                <a:latin typeface="DejaVu Sans"/>
+              </a:defRPr>
+            </a:pPr>
+            <a:r>
+              <a:t>Buyer and Supplier Agent negotiation · Human review and first paid pilots</a:t>
             </a:r>
           </a:p>
         </p:txBody>
       </p:sp>
-      <p:sp>
+      <p:sp xmlns:a="http://schemas.openxmlformats.org/drawingml/2006/main">
         <p:nvSpPr>
-          <p:cNvPr id="11" name="roadmap-milestone-1">
-            <a:extLst xmlns:a="http://schemas.openxmlformats.org/drawingml/2006/main">
-              <a:ext uri="{FF2B5EF4-FFF2-40B4-BE49-F238E27FC236}">
-                <a16:creationId xmlns:a16="http://schemas.microsoft.com/office/drawing/2014/main" id="{7B8351E9-CA1B-4C24-8F89-95D4BB0609EC}"/>
-              </a:ext>
-            </a:extLst>
-          </p:cNvPr>
-          <p:cNvSpPr>
-            <a:spLocks xmlns:a="http://schemas.openxmlformats.org/drawingml/2006/main" noGrp="1"/>
-          </p:cNvSpPr>
+          <p:cNvPr id="27" name="Rectangle 26"/>
+          <p:cNvSpPr/>
           <p:nvPr/>
         </p:nvSpPr>
         <p:spPr>
-          <a:xfrm xmlns:a="http://schemas.openxmlformats.org/drawingml/2006/main">
-            <a:off x="6286500" y="3771900"/>
-            <a:ext cx="5286375" cy="733425"/>
+          <a:xfrm>
+            <a:off x="4297680" y="4937760"/>
+            <a:ext cx="4069080" cy="1280160"/>
           </a:xfrm>
-          <a:prstGeom xmlns:a="http://schemas.openxmlformats.org/drawingml/2006/main" prst="rect">
+          <a:prstGeom prst="rect">
             <a:avLst/>
           </a:prstGeom>
-          <a:noFill xmlns:a="http://schemas.openxmlformats.org/drawingml/2006/main"/>
-          <a:ln xmlns:a="http://schemas.openxmlformats.org/drawingml/2006/main" w="0">
-            <a:noFill/>
-            <a:prstDash val="solid"/>
+          <a:solidFill>
+            <a:srgbClr val="FFFFFF"/>
+          </a:solidFill>
+          <a:ln w="12700">
+            <a:solidFill>
+              <a:srgbClr val="DCE1EE"/>
+            </a:solidFill>
           </a:ln>
         </p:spPr>
+        <p:style>
+          <a:lnRef idx="1">
+            <a:schemeClr val="accent1"/>
+          </a:lnRef>
+          <a:fillRef idx="3">
+            <a:schemeClr val="accent1"/>
+          </a:fillRef>
+          <a:effectRef idx="2">
+            <a:schemeClr val="accent1"/>
+          </a:effectRef>
+          <a:fontRef idx="minor">
+            <a:schemeClr val="lt1"/>
+          </a:fontRef>
+        </p:style>
         <p:txBody>
-          <a:bodyPr xmlns:a="http://schemas.openxmlformats.org/drawingml/2006/main" wrap="square" lIns="0" tIns="0" rIns="0" bIns="0" anchor="t">
-            <a:noAutofit/>
+          <a:bodyPr rtlCol="0" anchor="ctr"/>
+          <a:lstStyle/>
+          <a:p>
+            <a:pPr algn="ctr"/>
+          </a:p>
+        </p:txBody>
+      </p:sp>
+      <p:sp xmlns:a="http://schemas.openxmlformats.org/drawingml/2006/main">
+        <p:nvSpPr>
+          <p:cNvPr id="28" name="Rectangle 27"/>
+          <p:cNvSpPr/>
+          <p:nvPr/>
+        </p:nvSpPr>
+        <p:spPr>
+          <a:xfrm>
+            <a:off x="4297680" y="4937760"/>
+            <a:ext cx="73152" cy="1280160"/>
+          </a:xfrm>
+          <a:prstGeom prst="rect">
+            <a:avLst/>
+          </a:prstGeom>
+          <a:solidFill>
+            <a:srgbClr val="6C5CE7"/>
+          </a:solidFill>
+          <a:ln>
+            <a:noFill/>
+          </a:ln>
+        </p:spPr>
+        <p:style>
+          <a:lnRef idx="1">
+            <a:schemeClr val="accent1"/>
+          </a:lnRef>
+          <a:fillRef idx="3">
+            <a:schemeClr val="accent1"/>
+          </a:fillRef>
+          <a:effectRef idx="2">
+            <a:schemeClr val="accent1"/>
+          </a:effectRef>
+          <a:fontRef idx="minor">
+            <a:schemeClr val="lt1"/>
+          </a:fontRef>
+        </p:style>
+        <p:txBody>
+          <a:bodyPr rtlCol="0" anchor="ctr"/>
+          <a:lstStyle/>
+          <a:p>
+            <a:pPr algn="ctr"/>
+          </a:p>
+        </p:txBody>
+      </p:sp>
+      <p:sp xmlns:a="http://schemas.openxmlformats.org/drawingml/2006/main">
+        <p:nvSpPr>
+          <p:cNvPr id="29" name="TextBox 28"/>
+          <p:cNvSpPr txBox="1"/>
+          <p:nvPr/>
+        </p:nvSpPr>
+        <p:spPr>
+          <a:xfrm>
+            <a:off x="4526280" y="5047488"/>
+            <a:ext cx="3703320" cy="1051560"/>
+          </a:xfrm>
+          <a:prstGeom prst="rect">
+            <a:avLst/>
+          </a:prstGeom>
+          <a:noFill/>
+        </p:spPr>
+        <p:txBody>
+          <a:bodyPr wrap="square">
+            <a:spAutoFit/>
           </a:bodyPr>
-          <a:lstStyle xmlns:a="http://schemas.openxmlformats.org/drawingml/2006/main">
-            <a:defPPr algn="l">
-              <a:defRPr sz="1800" b="0">
-                <a:solidFill>
-                  <a:srgbClr val="4B526F"/>
-                </a:solidFill>
-                <a:latin typeface="DejaVu Sans"/>
-                <a:ea typeface="DejaVu Sans"/>
-                <a:cs typeface="DejaVu Sans"/>
-              </a:defRPr>
-            </a:defPPr>
-            <a:lvl1pPr algn="l">
-              <a:buNone/>
-              <a:defRPr sz="1800" b="0">
-                <a:solidFill>
-                  <a:srgbClr val="4B526F"/>
-                </a:solidFill>
-                <a:latin typeface="DejaVu Sans"/>
-                <a:ea typeface="DejaVu Sans"/>
-                <a:cs typeface="DejaVu Sans"/>
-              </a:defRPr>
-            </a:lvl1pPr>
-            <a:lvl2pPr algn="l">
-              <a:buNone/>
-              <a:defRPr sz="1800" b="0">
-                <a:solidFill>
-                  <a:srgbClr val="4B526F"/>
-                </a:solidFill>
-                <a:latin typeface="DejaVu Sans"/>
-                <a:ea typeface="DejaVu Sans"/>
-                <a:cs typeface="DejaVu Sans"/>
-              </a:defRPr>
-            </a:lvl2pPr>
-            <a:lvl3pPr algn="l">
-              <a:buNone/>
-              <a:defRPr sz="1800" b="0">
-                <a:solidFill>
-                  <a:srgbClr val="4B526F"/>
-                </a:solidFill>
-                <a:latin typeface="DejaVu Sans"/>
-                <a:ea typeface="DejaVu Sans"/>
-                <a:cs typeface="DejaVu Sans"/>
-              </a:defRPr>
-            </a:lvl3pPr>
-            <a:lvl4pPr algn="l">
-              <a:buNone/>
-              <a:defRPr sz="1800" b="0">
-                <a:solidFill>
-                  <a:srgbClr val="4B526F"/>
-                </a:solidFill>
-                <a:latin typeface="DejaVu Sans"/>
-                <a:ea typeface="DejaVu Sans"/>
-                <a:cs typeface="DejaVu Sans"/>
-              </a:defRPr>
-            </a:lvl4pPr>
-            <a:lvl5pPr algn="l">
-              <a:buNone/>
-              <a:defRPr sz="1800" b="0">
-                <a:solidFill>
-                  <a:srgbClr val="4B526F"/>
-                </a:solidFill>
-                <a:latin typeface="DejaVu Sans"/>
-                <a:ea typeface="DejaVu Sans"/>
-                <a:cs typeface="DejaVu Sans"/>
-              </a:defRPr>
-            </a:lvl5pPr>
-            <a:lvl6pPr algn="l">
-              <a:buNone/>
-              <a:defRPr sz="1800" b="0">
-                <a:solidFill>
-                  <a:srgbClr val="4B526F"/>
-                </a:solidFill>
-                <a:latin typeface="DejaVu Sans"/>
-                <a:ea typeface="DejaVu Sans"/>
-                <a:cs typeface="DejaVu Sans"/>
-              </a:defRPr>
-            </a:lvl6pPr>
-            <a:lvl7pPr algn="l">
-              <a:buNone/>
-              <a:defRPr sz="1800" b="0">
-                <a:solidFill>
-                  <a:srgbClr val="4B526F"/>
-                </a:solidFill>
-                <a:latin typeface="DejaVu Sans"/>
-                <a:ea typeface="DejaVu Sans"/>
-                <a:cs typeface="DejaVu Sans"/>
-              </a:defRPr>
-            </a:lvl7pPr>
-            <a:lvl8pPr algn="l">
-              <a:buNone/>
-              <a:defRPr sz="1800" b="0">
-                <a:solidFill>
-                  <a:srgbClr val="4B526F"/>
-                </a:solidFill>
-                <a:latin typeface="DejaVu Sans"/>
-                <a:ea typeface="DejaVu Sans"/>
-                <a:cs typeface="DejaVu Sans"/>
-              </a:defRPr>
-            </a:lvl8pPr>
-            <a:lvl9pPr algn="l">
-              <a:buNone/>
-              <a:defRPr sz="1800" b="0">
-                <a:solidFill>
-                  <a:srgbClr val="4B526F"/>
-                </a:solidFill>
-                <a:latin typeface="DejaVu Sans"/>
-                <a:ea typeface="DejaVu Sans"/>
-                <a:cs typeface="DejaVu Sans"/>
-              </a:defRPr>
-            </a:lvl9pPr>
-          </a:lstStyle>
-          <a:p xmlns:a="http://schemas.openxmlformats.org/drawingml/2006/main">
+          <a:lstStyle/>
+          <a:p>
             <a:pPr algn="l">
-              <a:lnSpc>
-                <a:spcPct val="112000"/>
-              </a:lnSpc>
-              <a:buNone/>
-              <a:defRPr sz="1800" b="0">
-                <a:solidFill>
-                  <a:srgbClr val="4B526F"/>
-                </a:solidFill>
-                <a:latin typeface="DejaVu Sans"/>
-                <a:ea typeface="DejaVu Sans"/>
-                <a:cs typeface="DejaVu Sans"/>
+              <a:defRPr sz="1400" b="1">
+                <a:solidFill>
+                  <a:srgbClr val="6C5CE7"/>
+                </a:solidFill>
+                <a:latin typeface="DejaVu Sans"/>
               </a:defRPr>
             </a:pPr>
             <a:r>
-              <a:rPr sz="1800" b="0">
-                <a:solidFill>
-                  <a:srgbClr val="4B526F"/>
-                </a:solidFill>
-                <a:latin typeface="DejaVu Sans"/>
-                <a:ea typeface="DejaVu Sans"/>
-                <a:cs typeface="DejaVu Sans"/>
-              </a:rPr>
-              <a:t>Buyer and Supplier Agent negotiation</a:t>
+              <a:t>Months 13–18</a:t>
             </a:r>
           </a:p>
-          <a:p xmlns:a="http://schemas.openxmlformats.org/drawingml/2006/main">
+          <a:p>
             <a:pPr algn="l">
-              <a:lnSpc>
-                <a:spcPct val="112000"/>
-              </a:lnSpc>
-              <a:buNone/>
-              <a:defRPr sz="1800" b="0">
-                <a:solidFill>
-                  <a:srgbClr val="4B526F"/>
-                </a:solidFill>
-                <a:latin typeface="DejaVu Sans"/>
-                <a:ea typeface="DejaVu Sans"/>
-                <a:cs typeface="DejaVu Sans"/>
+              <a:defRPr sz="1100" b="0">
+                <a:solidFill>
+                  <a:srgbClr val="5A6578"/>
+                </a:solidFill>
+                <a:latin typeface="DejaVu Sans"/>
               </a:defRPr>
             </a:pPr>
             <a:r>
-              <a:rPr sz="1800" b="0">
-                <a:solidFill>
-                  <a:srgbClr val="4B526F"/>
-                </a:solidFill>
-                <a:latin typeface="DejaVu Sans"/>
-                <a:ea typeface="DejaVu Sans"/>
-                <a:cs typeface="DejaVu Sans"/>
-              </a:rPr>
-              <a:t>Human review and first paid pilots</a:t>
+              <a:t>Three paid pilots and renewal tests · Initial recurring revenue target</a:t>
             </a:r>
           </a:p>
         </p:txBody>
       </p:sp>
-      <p:sp>
+      <p:sp xmlns:a="http://schemas.openxmlformats.org/drawingml/2006/main">
         <p:nvSpPr>
-          <p:cNvPr id="12" name="roadmap-time-2">
-            <a:extLst xmlns:a="http://schemas.openxmlformats.org/drawingml/2006/main">
-              <a:ext uri="{FF2B5EF4-FFF2-40B4-BE49-F238E27FC236}">
-                <a16:creationId xmlns:a16="http://schemas.microsoft.com/office/drawing/2014/main" id="{8D7E0CFA-79E9-40AB-9440-E1EADA180A77}"/>
-              </a:ext>
-            </a:extLst>
-          </p:cNvPr>
-          <p:cNvSpPr>
-            <a:spLocks xmlns:a="http://schemas.openxmlformats.org/drawingml/2006/main" noGrp="1"/>
-          </p:cNvSpPr>
+          <p:cNvPr id="30" name="Rectangle 29"/>
+          <p:cNvSpPr/>
           <p:nvPr/>
         </p:nvSpPr>
         <p:spPr>
-          <a:xfrm xmlns:a="http://schemas.openxmlformats.org/drawingml/2006/main">
-            <a:off x="6286500" y="4591050"/>
-            <a:ext cx="5286375" cy="352425"/>
+          <a:xfrm>
+            <a:off x="8595360" y="1874519"/>
+            <a:ext cx="3044952" cy="4343400"/>
           </a:xfrm>
-          <a:prstGeom xmlns:a="http://schemas.openxmlformats.org/drawingml/2006/main" prst="rect">
+          <a:prstGeom prst="rect">
             <a:avLst/>
           </a:prstGeom>
-          <a:noFill xmlns:a="http://schemas.openxmlformats.org/drawingml/2006/main"/>
-          <a:ln xmlns:a="http://schemas.openxmlformats.org/drawingml/2006/main" w="0">
-            <a:noFill/>
-            <a:prstDash val="solid"/>
+          <a:solidFill>
+            <a:srgbClr val="FFFFFF"/>
+          </a:solidFill>
+          <a:ln w="12700">
+            <a:solidFill>
+              <a:srgbClr val="DCE1EE"/>
+            </a:solidFill>
           </a:ln>
         </p:spPr>
+        <p:style>
+          <a:lnRef idx="1">
+            <a:schemeClr val="accent1"/>
+          </a:lnRef>
+          <a:fillRef idx="3">
+            <a:schemeClr val="accent1"/>
+          </a:fillRef>
+          <a:effectRef idx="2">
+            <a:schemeClr val="accent1"/>
+          </a:effectRef>
+          <a:fontRef idx="minor">
+            <a:schemeClr val="lt1"/>
+          </a:fontRef>
+        </p:style>
         <p:txBody>
-          <a:bodyPr xmlns:a="http://schemas.openxmlformats.org/drawingml/2006/main" wrap="square" lIns="0" tIns="0" rIns="0" bIns="0" anchor="t">
-            <a:noAutofit/>
-          </a:bodyPr>
-          <a:lstStyle xmlns:a="http://schemas.openxmlformats.org/drawingml/2006/main">
-            <a:defPPr algn="l">
-              <a:defRPr sz="1950" b="1">
-                <a:solidFill>
-                  <a:srgbClr val="6847F5"/>
-                </a:solidFill>
-                <a:latin typeface="DejaVu Sans"/>
-                <a:ea typeface="DejaVu Sans"/>
-                <a:cs typeface="DejaVu Sans"/>
-              </a:defRPr>
-            </a:defPPr>
-            <a:lvl1pPr algn="l">
-              <a:buNone/>
-              <a:defRPr sz="1950" b="1">
-                <a:solidFill>
-                  <a:srgbClr val="6847F5"/>
-                </a:solidFill>
-                <a:latin typeface="DejaVu Sans"/>
-                <a:ea typeface="DejaVu Sans"/>
-                <a:cs typeface="DejaVu Sans"/>
-              </a:defRPr>
-            </a:lvl1pPr>
-            <a:lvl2pPr algn="l">
-              <a:buNone/>
-              <a:defRPr sz="1950" b="1">
-                <a:solidFill>
-                  <a:srgbClr val="6847F5"/>
-                </a:solidFill>
-                <a:latin typeface="DejaVu Sans"/>
-                <a:ea typeface="DejaVu Sans"/>
-                <a:cs typeface="DejaVu Sans"/>
-              </a:defRPr>
-            </a:lvl2pPr>
-            <a:lvl3pPr algn="l">
-              <a:buNone/>
-              <a:defRPr sz="1950" b="1">
-                <a:solidFill>
-                  <a:srgbClr val="6847F5"/>
-                </a:solidFill>
-                <a:latin typeface="DejaVu Sans"/>
-                <a:ea typeface="DejaVu Sans"/>
-                <a:cs typeface="DejaVu Sans"/>
-              </a:defRPr>
-            </a:lvl3pPr>
-            <a:lvl4pPr algn="l">
-              <a:buNone/>
-              <a:defRPr sz="1950" b="1">
-                <a:solidFill>
-                  <a:srgbClr val="6847F5"/>
-                </a:solidFill>
-                <a:latin typeface="DejaVu Sans"/>
-                <a:ea typeface="DejaVu Sans"/>
-                <a:cs typeface="DejaVu Sans"/>
-              </a:defRPr>
-            </a:lvl4pPr>
-            <a:lvl5pPr algn="l">
-              <a:buNone/>
-              <a:defRPr sz="1950" b="1">
-                <a:solidFill>
-                  <a:srgbClr val="6847F5"/>
-                </a:solidFill>
-                <a:latin typeface="DejaVu Sans"/>
-                <a:ea typeface="DejaVu Sans"/>
-                <a:cs typeface="DejaVu Sans"/>
-              </a:defRPr>
-            </a:lvl5pPr>
-            <a:lvl6pPr algn="l">
-              <a:buNone/>
-              <a:defRPr sz="1950" b="1">
-                <a:solidFill>
-                  <a:srgbClr val="6847F5"/>
-                </a:solidFill>
-                <a:latin typeface="DejaVu Sans"/>
-                <a:ea typeface="DejaVu Sans"/>
-                <a:cs typeface="DejaVu Sans"/>
-              </a:defRPr>
-            </a:lvl6pPr>
-            <a:lvl7pPr algn="l">
-              <a:buNone/>
-              <a:defRPr sz="1950" b="1">
-                <a:solidFill>
-                  <a:srgbClr val="6847F5"/>
-                </a:solidFill>
-                <a:latin typeface="DejaVu Sans"/>
-                <a:ea typeface="DejaVu Sans"/>
-                <a:cs typeface="DejaVu Sans"/>
-              </a:defRPr>
-            </a:lvl7pPr>
-            <a:lvl8pPr algn="l">
-              <a:buNone/>
-              <a:defRPr sz="1950" b="1">
-                <a:solidFill>
-                  <a:srgbClr val="6847F5"/>
-                </a:solidFill>
-                <a:latin typeface="DejaVu Sans"/>
-                <a:ea typeface="DejaVu Sans"/>
-                <a:cs typeface="DejaVu Sans"/>
-              </a:defRPr>
-            </a:lvl8pPr>
-            <a:lvl9pPr algn="l">
-              <a:buNone/>
-              <a:defRPr sz="1950" b="1">
-                <a:solidFill>
-                  <a:srgbClr val="6847F5"/>
-                </a:solidFill>
-                <a:latin typeface="DejaVu Sans"/>
-                <a:ea typeface="DejaVu Sans"/>
-                <a:cs typeface="DejaVu Sans"/>
-              </a:defRPr>
-            </a:lvl9pPr>
-          </a:lstStyle>
-          <a:p xmlns:a="http://schemas.openxmlformats.org/drawingml/2006/main">
-            <a:pPr algn="l">
-              <a:lnSpc>
-                <a:spcPct val="112000"/>
-              </a:lnSpc>
-              <a:buNone/>
-              <a:defRPr sz="1950" b="1">
-                <a:solidFill>
-                  <a:srgbClr val="6847F5"/>
-                </a:solidFill>
-                <a:latin typeface="DejaVu Sans"/>
-                <a:ea typeface="DejaVu Sans"/>
-                <a:cs typeface="DejaVu Sans"/>
-              </a:defRPr>
-            </a:pPr>
-            <a:r>
-              <a:rPr sz="1950" b="1">
-                <a:solidFill>
-                  <a:srgbClr val="6847F5"/>
-                </a:solidFill>
-                <a:latin typeface="DejaVu Sans"/>
-                <a:ea typeface="DejaVu Sans"/>
-                <a:cs typeface="DejaVu Sans"/>
-              </a:rPr>
-              <a:t>Months 13–18</a:t>
-            </a:r>
+          <a:bodyPr rtlCol="0" anchor="ctr"/>
+          <a:lstStyle/>
+          <a:p>
+            <a:pPr algn="ctr"/>
           </a:p>
         </p:txBody>
       </p:sp>
-      <p:sp>
+      <p:sp xmlns:a="http://schemas.openxmlformats.org/drawingml/2006/main">
         <p:nvSpPr>
-          <p:cNvPr id="13" name="roadmap-milestone-2">
-            <a:extLst xmlns:a="http://schemas.openxmlformats.org/drawingml/2006/main">
-              <a:ext uri="{FF2B5EF4-FFF2-40B4-BE49-F238E27FC236}">
-                <a16:creationId xmlns:a16="http://schemas.microsoft.com/office/drawing/2014/main" id="{0A7DC8E3-160B-4083-8393-D345E188F82D}"/>
-              </a:ext>
-            </a:extLst>
-          </p:cNvPr>
-          <p:cNvSpPr>
-            <a:spLocks xmlns:a="http://schemas.openxmlformats.org/drawingml/2006/main" noGrp="1"/>
-          </p:cNvSpPr>
+          <p:cNvPr id="31" name="Rectangle 30"/>
+          <p:cNvSpPr/>
           <p:nvPr/>
         </p:nvSpPr>
         <p:spPr>
-          <a:xfrm xmlns:a="http://schemas.openxmlformats.org/drawingml/2006/main">
-            <a:off x="6286500" y="5038725"/>
-            <a:ext cx="5286375" cy="733425"/>
+          <a:xfrm>
+            <a:off x="8595360" y="1874519"/>
+            <a:ext cx="3044952" cy="73152"/>
           </a:xfrm>
-          <a:prstGeom xmlns:a="http://schemas.openxmlformats.org/drawingml/2006/main" prst="rect">
+          <a:prstGeom prst="rect">
             <a:avLst/>
           </a:prstGeom>
-          <a:noFill xmlns:a="http://schemas.openxmlformats.org/drawingml/2006/main"/>
-          <a:ln xmlns:a="http://schemas.openxmlformats.org/drawingml/2006/main" w="0">
+          <a:solidFill>
+            <a:srgbClr val="6C5CE7"/>
+          </a:solidFill>
+          <a:ln>
             <a:noFill/>
-            <a:prstDash val="solid"/>
           </a:ln>
         </p:spPr>
+        <p:style>
+          <a:lnRef idx="1">
+            <a:schemeClr val="accent1"/>
+          </a:lnRef>
+          <a:fillRef idx="3">
+            <a:schemeClr val="accent1"/>
+          </a:fillRef>
+          <a:effectRef idx="2">
+            <a:schemeClr val="accent1"/>
+          </a:effectRef>
+          <a:fontRef idx="minor">
+            <a:schemeClr val="lt1"/>
+          </a:fontRef>
+        </p:style>
         <p:txBody>
-          <a:bodyPr xmlns:a="http://schemas.openxmlformats.org/drawingml/2006/main" wrap="square" lIns="0" tIns="0" rIns="0" bIns="0" anchor="t">
-            <a:noAutofit/>
+          <a:bodyPr rtlCol="0" anchor="ctr"/>
+          <a:lstStyle/>
+          <a:p>
+            <a:pPr algn="ctr"/>
+          </a:p>
+        </p:txBody>
+      </p:sp>
+      <p:sp xmlns:a="http://schemas.openxmlformats.org/drawingml/2006/main">
+        <p:nvSpPr>
+          <p:cNvPr id="32" name="TextBox 31"/>
+          <p:cNvSpPr txBox="1"/>
+          <p:nvPr/>
+        </p:nvSpPr>
+        <p:spPr>
+          <a:xfrm>
+            <a:off x="8686800" y="2057400"/>
+            <a:ext cx="2862072" cy="365760"/>
+          </a:xfrm>
+          <a:prstGeom prst="rect">
+            <a:avLst/>
+          </a:prstGeom>
+          <a:noFill/>
+        </p:spPr>
+        <p:txBody>
+          <a:bodyPr wrap="none">
+            <a:spAutoFit/>
           </a:bodyPr>
-          <a:lstStyle xmlns:a="http://schemas.openxmlformats.org/drawingml/2006/main">
-            <a:defPPr algn="l">
-              <a:defRPr sz="1800" b="0">
-                <a:solidFill>
-                  <a:srgbClr val="4B526F"/>
-                </a:solidFill>
-                <a:latin typeface="DejaVu Sans"/>
-                <a:ea typeface="DejaVu Sans"/>
-                <a:cs typeface="DejaVu Sans"/>
-              </a:defRPr>
-            </a:defPPr>
-            <a:lvl1pPr algn="l">
-              <a:buNone/>
-              <a:defRPr sz="1800" b="0">
-                <a:solidFill>
-                  <a:srgbClr val="4B526F"/>
-                </a:solidFill>
-                <a:latin typeface="DejaVu Sans"/>
-                <a:ea typeface="DejaVu Sans"/>
-                <a:cs typeface="DejaVu Sans"/>
-              </a:defRPr>
-            </a:lvl1pPr>
-            <a:lvl2pPr algn="l">
-              <a:buNone/>
-              <a:defRPr sz="1800" b="0">
-                <a:solidFill>
-                  <a:srgbClr val="4B526F"/>
-                </a:solidFill>
-                <a:latin typeface="DejaVu Sans"/>
-                <a:ea typeface="DejaVu Sans"/>
-                <a:cs typeface="DejaVu Sans"/>
-              </a:defRPr>
-            </a:lvl2pPr>
-            <a:lvl3pPr algn="l">
-              <a:buNone/>
-              <a:defRPr sz="1800" b="0">
-                <a:solidFill>
-                  <a:srgbClr val="4B526F"/>
-                </a:solidFill>
-                <a:latin typeface="DejaVu Sans"/>
-                <a:ea typeface="DejaVu Sans"/>
-                <a:cs typeface="DejaVu Sans"/>
-              </a:defRPr>
-            </a:lvl3pPr>
-            <a:lvl4pPr algn="l">
-              <a:buNone/>
-              <a:defRPr sz="1800" b="0">
-                <a:solidFill>
-                  <a:srgbClr val="4B526F"/>
-                </a:solidFill>
-                <a:latin typeface="DejaVu Sans"/>
-                <a:ea typeface="DejaVu Sans"/>
-                <a:cs typeface="DejaVu Sans"/>
-              </a:defRPr>
-            </a:lvl4pPr>
-            <a:lvl5pPr algn="l">
-              <a:buNone/>
-              <a:defRPr sz="1800" b="0">
-                <a:solidFill>
-                  <a:srgbClr val="4B526F"/>
-                </a:solidFill>
-                <a:latin typeface="DejaVu Sans"/>
-                <a:ea typeface="DejaVu Sans"/>
-                <a:cs typeface="DejaVu Sans"/>
-              </a:defRPr>
-            </a:lvl5pPr>
-            <a:lvl6pPr algn="l">
-              <a:buNone/>
-              <a:defRPr sz="1800" b="0">
-                <a:solidFill>
-                  <a:srgbClr val="4B526F"/>
-                </a:solidFill>
-                <a:latin typeface="DejaVu Sans"/>
-                <a:ea typeface="DejaVu Sans"/>
-                <a:cs typeface="DejaVu Sans"/>
-              </a:defRPr>
-            </a:lvl6pPr>
-            <a:lvl7pPr algn="l">
-              <a:buNone/>
-              <a:defRPr sz="1800" b="0">
-                <a:solidFill>
-                  <a:srgbClr val="4B526F"/>
-                </a:solidFill>
-                <a:latin typeface="DejaVu Sans"/>
-                <a:ea typeface="DejaVu Sans"/>
-                <a:cs typeface="DejaVu Sans"/>
-              </a:defRPr>
-            </a:lvl7pPr>
-            <a:lvl8pPr algn="l">
-              <a:buNone/>
-              <a:defRPr sz="1800" b="0">
-                <a:solidFill>
-                  <a:srgbClr val="4B526F"/>
-                </a:solidFill>
-                <a:latin typeface="DejaVu Sans"/>
-                <a:ea typeface="DejaVu Sans"/>
-                <a:cs typeface="DejaVu Sans"/>
-              </a:defRPr>
-            </a:lvl8pPr>
-            <a:lvl9pPr algn="l">
-              <a:buNone/>
-              <a:defRPr sz="1800" b="0">
-                <a:solidFill>
-                  <a:srgbClr val="4B526F"/>
-                </a:solidFill>
-                <a:latin typeface="DejaVu Sans"/>
-                <a:ea typeface="DejaVu Sans"/>
-                <a:cs typeface="DejaVu Sans"/>
-              </a:defRPr>
-            </a:lvl9pPr>
-          </a:lstStyle>
-          <a:p xmlns:a="http://schemas.openxmlformats.org/drawingml/2006/main">
-            <a:pPr algn="l">
-              <a:lnSpc>
-                <a:spcPct val="112000"/>
-              </a:lnSpc>
-              <a:buNone/>
-              <a:defRPr sz="1800" b="0">
-                <a:solidFill>
-                  <a:srgbClr val="4B526F"/>
-                </a:solidFill>
-                <a:latin typeface="DejaVu Sans"/>
-                <a:ea typeface="DejaVu Sans"/>
-                <a:cs typeface="DejaVu Sans"/>
+          <a:lstStyle/>
+          <a:p>
+            <a:pPr algn="ctr">
+              <a:defRPr sz="1500" b="1">
+                <a:solidFill>
+                  <a:srgbClr val="10142B"/>
+                </a:solidFill>
+                <a:latin typeface="DejaVu Sans"/>
               </a:defRPr>
             </a:pPr>
             <a:r>
-              <a:rPr sz="1800" b="0">
-                <a:solidFill>
-                  <a:srgbClr val="4B526F"/>
-                </a:solidFill>
-                <a:latin typeface="DejaVu Sans"/>
-                <a:ea typeface="DejaVu Sans"/>
-                <a:cs typeface="DejaVu Sans"/>
-              </a:rPr>
-              <a:t>Three paid pilots and renewal tests</a:t>
-            </a:r>
-          </a:p>
-          <a:p xmlns:a="http://schemas.openxmlformats.org/drawingml/2006/main">
-            <a:pPr algn="l">
-              <a:lnSpc>
-                <a:spcPct val="112000"/>
-              </a:lnSpc>
-              <a:buNone/>
-              <a:defRPr sz="1800" b="0">
-                <a:solidFill>
-                  <a:srgbClr val="4B526F"/>
-                </a:solidFill>
-                <a:latin typeface="DejaVu Sans"/>
-                <a:ea typeface="DejaVu Sans"/>
-                <a:cs typeface="DejaVu Sans"/>
-              </a:defRPr>
-            </a:pPr>
-            <a:r>
-              <a:rPr sz="1800" b="0">
-                <a:solidFill>
-                  <a:srgbClr val="4B526F"/>
-                </a:solidFill>
-                <a:latin typeface="DejaVu Sans"/>
-                <a:ea typeface="DejaVu Sans"/>
-                <a:cs typeface="DejaVu Sans"/>
-              </a:rPr>
-              <a:t>Initial recurring revenue target</a:t>
+              <a:t>Live Pitch Deck</a:t>
             </a:r>
           </a:p>
         </p:txBody>
       </p:sp>
       <p:pic xmlns:a="http://schemas.openxmlformats.org/drawingml/2006/main" xmlns:r="http://schemas.openxmlformats.org/officeDocument/2006/relationships">
         <p:nvPicPr>
-          <p:cNvPr id="15" name="Picture 14" descr="qrcode_pitch.png"/>
+          <p:cNvPr id="33" name="Picture 32" descr="image.png">
+            <a:hlinkClick r:id="rId4"/>
+          </p:cNvPr>
           <p:cNvPicPr>
             <a:picLocks noChangeAspect="1"/>
           </p:cNvPicPr>
@@ -17739,14 +16731,105 @@
         </p:blipFill>
         <p:spPr>
           <a:xfrm>
-            <a:off x="4127500" y="4635500"/>
-            <a:ext cx="914400" cy="914400"/>
+            <a:off x="9157716" y="2560320"/>
+            <a:ext cx="1920240" cy="1920240"/>
           </a:xfrm>
           <a:prstGeom prst="rect">
             <a:avLst/>
           </a:prstGeom>
         </p:spPr>
       </p:pic>
+      <p:sp xmlns:a="http://schemas.openxmlformats.org/drawingml/2006/main">
+        <p:nvSpPr>
+          <p:cNvPr id="34" name="TextBox 33"/>
+          <p:cNvSpPr txBox="1"/>
+          <p:nvPr/>
+        </p:nvSpPr>
+        <p:spPr>
+          <a:xfrm>
+            <a:off x="8686800" y="4617720"/>
+            <a:ext cx="2862072" cy="502920"/>
+          </a:xfrm>
+          <a:prstGeom prst="rect">
+            <a:avLst/>
+          </a:prstGeom>
+          <a:noFill/>
+        </p:spPr>
+        <p:txBody>
+          <a:bodyPr wrap="square">
+            <a:spAutoFit/>
+          </a:bodyPr>
+          <a:lstStyle/>
+          <a:p>
+            <a:pPr algn="ctr">
+              <a:defRPr sz="1050" b="0">
+                <a:solidFill>
+                  <a:srgbClr val="5A6578"/>
+                </a:solidFill>
+                <a:latin typeface="DejaVu Sans"/>
+              </a:defRPr>
+            </a:pPr>
+            <a:r>
+              <a:t>Scan camera or tap below to view presentation</a:t>
+            </a:r>
+          </a:p>
+        </p:txBody>
+      </p:sp>
+      <p:sp xmlns:a="http://schemas.openxmlformats.org/drawingml/2006/main">
+        <p:nvSpPr>
+          <p:cNvPr id="35" name="Rounded Rectangle 34">
+            <a:hlinkClick xmlns:ns0="http://schemas.openxmlformats.org/officeDocument/2006/relationships" ns0:id="rId4"/>
+          </p:cNvPr>
+          <p:cNvSpPr/>
+          <p:nvPr/>
+        </p:nvSpPr>
+        <p:spPr>
+          <a:xfrm>
+            <a:off x="8823960" y="5349240"/>
+            <a:ext cx="2587752" cy="475488"/>
+          </a:xfrm>
+          <a:prstGeom prst="roundRect">
+            <a:avLst/>
+          </a:prstGeom>
+          <a:solidFill>
+            <a:srgbClr val="6C5CE7"/>
+          </a:solidFill>
+          <a:ln>
+            <a:noFill/>
+          </a:ln>
+        </p:spPr>
+        <p:style>
+          <a:lnRef idx="1">
+            <a:schemeClr val="accent1"/>
+          </a:lnRef>
+          <a:fillRef idx="3">
+            <a:schemeClr val="accent1"/>
+          </a:fillRef>
+          <a:effectRef idx="2">
+            <a:schemeClr val="accent1"/>
+          </a:effectRef>
+          <a:fontRef idx="minor">
+            <a:schemeClr val="lt1"/>
+          </a:fontRef>
+        </p:style>
+        <p:txBody>
+          <a:bodyPr rtlCol="0" anchor="ctr"/>
+          <a:lstStyle/>
+          <a:p>
+            <a:pPr algn="ctr">
+              <a:defRPr sz="1200" b="1">
+                <a:solidFill>
+                  <a:srgbClr val="FFFFFF"/>
+                </a:solidFill>
+                <a:latin typeface="DejaVu Sans"/>
+              </a:defRPr>
+            </a:pPr>
+            <a:r>
+              <a:t>Open Online Deck ↗</a:t>
+            </a:r>
+          </a:p>
+        </p:txBody>
+      </p:sp>
     </p:spTree>
     <p:extLst>
       <p:ext uri="{BB962C8B-B14F-4D97-AF65-F5344CB8AC3E}">

</xml_diff>

<commit_message>
Update slide 1, 2, 3 messaging to include Sourcing and negotiation rounds across HTML, PPTX, and PDF
</commit_message>
<xml_diff>
--- a/docs/publish/pitch-agentic-procurement/Finux-Labs-Procurement-AI-Pitch-15-Slides.pptx
+++ b/docs/publish/pitch-agentic-procurement/Finux-Labs-Procurement-AI-Pitch-15-Slides.pptx
@@ -5666,14 +5666,6 @@
               </a:defRPr>
             </a:pPr>
             <a:r>
-              <a:rPr sz="2025" b="0">
-                <a:solidFill>
-                  <a:srgbClr val="CBD2EB"/>
-                </a:solidFill>
-                <a:latin typeface="DejaVu Sans"/>
-                <a:ea typeface="DejaVu Sans"/>
-                <a:cs typeface="DejaVu Sans"/>
-              </a:rPr>
               <a:t>Supplier cost assessment</a:t>
             </a:r>
           </a:p>
@@ -5693,15 +5685,7 @@
               </a:defRPr>
             </a:pPr>
             <a:r>
-              <a:rPr sz="2025" b="0">
-                <a:solidFill>
-                  <a:srgbClr val="CBD2EB"/>
-                </a:solidFill>
-                <a:latin typeface="DejaVu Sans"/>
-                <a:ea typeface="DejaVu Sans"/>
-                <a:cs typeface="DejaVu Sans"/>
-              </a:rPr>
-              <a:t>and pricing negotiation</a:t>
+              <a:t>and Sourcing</a:t>
             </a:r>
           </a:p>
         </p:txBody>
@@ -19189,15 +19173,7 @@
               </a:defRPr>
             </a:pPr>
             <a:r>
-              <a:rPr sz="3225" b="1">
-                <a:solidFill>
-                  <a:srgbClr val="171C3D"/>
-                </a:solidFill>
-                <a:latin typeface="DejaVu Sans"/>
-                <a:ea typeface="DejaVu Sans"/>
-                <a:cs typeface="DejaVu Sans"/>
-              </a:rPr>
-              <a:t>The complexity of price negotiation</a:t>
+              <a:t>The complexity of Supplier Sourcing</a:t>
             </a:r>
           </a:p>
         </p:txBody>
@@ -20625,15 +20601,7 @@
               </a:defRPr>
             </a:pPr>
             <a:r>
-              <a:rPr sz="3225" b="1">
-                <a:solidFill>
-                  <a:srgbClr val="171C3D"/>
-                </a:solidFill>
-                <a:latin typeface="DejaVu Sans"/>
-                <a:ea typeface="DejaVu Sans"/>
-                <a:cs typeface="DejaVu Sans"/>
-              </a:rPr>
-              <a:t>Repeated pricing rounds take time</a:t>
+              <a:t>Repeated negotiation rounds take time</a:t>
             </a:r>
           </a:p>
         </p:txBody>

</xml_diff>

<commit_message>
Move Finux Labs branding to bottom right below picture on Slide 1 across HTML, PPTX, and PDF
</commit_message>
<xml_diff>
--- a/docs/publish/pitch-agentic-procurement/Finux-Labs-Procurement-AI-Pitch-15-Slides.pptx
+++ b/docs/publish/pitch-agentic-procurement/Finux-Labs-Procurement-AI-Pitch-15-Slides.pptx
@@ -5168,8 +5168,8 @@
         </p:nvSpPr>
         <p:spPr>
           <a:xfrm xmlns:a="http://schemas.openxmlformats.org/drawingml/2006/main">
-            <a:off x="590550" y="533400"/>
-            <a:ext cx="5048250" cy="619125"/>
+            <a:off x="8686800" y="6263640"/>
+            <a:ext cx="2926080" cy="365760"/>
           </a:xfrm>
           <a:prstGeom xmlns:a="http://schemas.openxmlformats.org/drawingml/2006/main" prst="rect">
             <a:avLst/>
@@ -5181,7 +5181,7 @@
           </a:ln>
         </p:spPr>
         <p:txBody>
-          <a:bodyPr xmlns:a="http://schemas.openxmlformats.org/drawingml/2006/main" wrap="square" lIns="0" tIns="0" rIns="0" bIns="0" anchor="t">
+          <a:bodyPr xmlns:a="http://schemas.openxmlformats.org/drawingml/2006/main" wrap="none" lIns="0" tIns="0" rIns="0" bIns="0" anchor="t">
             <a:noAutofit/>
           </a:bodyPr>
           <a:lstStyle xmlns:a="http://schemas.openxmlformats.org/drawingml/2006/main">
@@ -5296,14 +5296,14 @@
             </a:lvl9pPr>
           </a:lstStyle>
           <a:p xmlns:a="http://schemas.openxmlformats.org/drawingml/2006/main">
-            <a:pPr algn="l">
+            <a:pPr algn="r">
               <a:lnSpc>
                 <a:spcPct val="112000"/>
               </a:lnSpc>
               <a:buNone/>
-              <a:defRPr sz="3900" b="1">
-                <a:solidFill>
-                  <a:srgbClr val="F6F7FF"/>
+              <a:defRPr sz="1500" b="1">
+                <a:solidFill>
+                  <a:srgbClr val="CBD2EB"/>
                 </a:solidFill>
                 <a:latin typeface="DejaVu Sans"/>
                 <a:ea typeface="DejaVu Sans"/>
@@ -5311,14 +5311,6 @@
               </a:defRPr>
             </a:pPr>
             <a:r>
-              <a:rPr sz="3900" b="1">
-                <a:solidFill>
-                  <a:srgbClr val="F6F7FF"/>
-                </a:solidFill>
-                <a:latin typeface="DejaVu Sans"/>
-                <a:ea typeface="DejaVu Sans"/>
-                <a:cs typeface="DejaVu Sans"/>
-              </a:rPr>
               <a:t>Finux Labs</a:t>
             </a:r>
           </a:p>

</xml_diff>

<commit_message>
Update Slide 1 headline to 2 lines, adjust hero text position and background image offset across HTML, PPTX, and PDF
</commit_message>
<xml_diff>
--- a/docs/publish/pitch-agentic-procurement/Finux-Labs-Procurement-AI-Pitch-15-Slides.pptx
+++ b/docs/publish/pitch-agentic-procurement/Finux-Labs-Procurement-AI-Pitch-15-Slides.pptx
@@ -5144,8 +5144,8 @@
         </p:blipFill>
         <p:spPr>
           <a:xfrm xmlns:a="http://schemas.openxmlformats.org/drawingml/2006/main" flipH="0" flipV="0">
-            <a:off x="0" y="0"/>
-            <a:ext cx="12192000" cy="6858000"/>
+            <a:off x="-502920" y="0"/>
+            <a:ext cx="12691872" cy="6858000"/>
           </a:xfrm>
           <a:prstGeom xmlns:a="http://schemas.openxmlformats.org/drawingml/2006/main" prst="rect">
             <a:avLst/>
@@ -5332,7 +5332,7 @@
         </p:nvSpPr>
         <p:spPr>
           <a:xfrm xmlns:a="http://schemas.openxmlformats.org/drawingml/2006/main">
-            <a:off x="619125" y="2057400"/>
+            <a:off x="914400" y="2240280"/>
             <a:ext cx="5381625" cy="2133600"/>
           </a:xfrm>
           <a:prstGeom xmlns:a="http://schemas.openxmlformats.org/drawingml/2006/main" prst="rect">
@@ -5475,7 +5475,7 @@
               </a:defRPr>
             </a:pPr>
             <a:r>
-              <a:t>Agentic Negotiator,</a:t>
+              <a:t>Procurement AI,</a:t>
             </a:r>
           </a:p>
           <a:p xmlns:a="http://schemas.openxmlformats.org/drawingml/2006/main">
@@ -5494,7 +5494,7 @@
               </a:defRPr>
             </a:pPr>
             <a:r>
-              <a:t>Procurement AI</a:t>
+              <a:t>Agentic Negotiator</a:t>
             </a:r>
           </a:p>
         </p:txBody>
@@ -5515,7 +5515,7 @@
         </p:nvSpPr>
         <p:spPr>
           <a:xfrm xmlns:a="http://schemas.openxmlformats.org/drawingml/2006/main">
-            <a:off x="619125" y="4505325"/>
+            <a:off x="914400" y="4617720"/>
             <a:ext cx="4762500" cy="876300"/>
           </a:xfrm>
           <a:prstGeom xmlns:a="http://schemas.openxmlformats.org/drawingml/2006/main" prst="rect">
@@ -5698,7 +5698,7 @@
         </p:nvSpPr>
         <p:spPr>
           <a:xfrm xmlns:a="http://schemas.openxmlformats.org/drawingml/2006/main">
-            <a:off x="619125" y="5924550"/>
+            <a:off x="914400" y="5989320"/>
             <a:ext cx="4762500" cy="400050"/>
           </a:xfrm>
           <a:prstGeom xmlns:a="http://schemas.openxmlformats.org/drawingml/2006/main" prst="rect">
@@ -5870,7 +5870,7 @@
         </p:nvSpPr>
         <p:spPr>
           <a:xfrm xmlns:a="http://schemas.openxmlformats.org/drawingml/2006/main">
-            <a:off x="619125" y="6391275"/>
+            <a:off x="914400" y="6446520"/>
             <a:ext cx="2857500" cy="238125"/>
           </a:xfrm>
           <a:prstGeom xmlns:a="http://schemas.openxmlformats.org/drawingml/2006/main" prst="rect">

</xml_diff>

<commit_message>
Add Slide 16 announcing presentation at AI Summit Vancouver 2026 with hero graphic and website link across HTML, PPTX, and PDF
</commit_message>
<xml_diff>
--- a/docs/publish/pitch-agentic-procurement/Finux-Labs-Procurement-AI-Pitch-15-Slides.pptx
+++ b/docs/publish/pitch-agentic-procurement/Finux-Labs-Procurement-AI-Pitch-15-Slides.pptx
@@ -23,6 +23,7 @@
     <p:sldId xmlns:r="http://schemas.openxmlformats.org/officeDocument/2006/relationships" id="268" r:id="R840e453bf4a146c8"/>
     <p:sldId xmlns:r="http://schemas.openxmlformats.org/officeDocument/2006/relationships" id="269" r:id="R93a56e6c49954db5"/>
     <p:sldId xmlns:r="http://schemas.openxmlformats.org/officeDocument/2006/relationships" id="270" r:id="R2cbe1b106bc249ab"/>
+    <p:sldId xmlns:ns0="http://schemas.openxmlformats.org/officeDocument/2006/relationships" id="271" ns0:id="rId21"/>
   </p:sldIdLst>
   <p:sldSz cx="12192000" cy="6858000"/>
   <p:notesSz cx="6858000" cy="9144000"/>
@@ -18987,6 +18988,401 @@
 </p:sld>
 </file>
 
+<file path=ppt/slides/slide16.xml><?xml version="1.0" encoding="utf-8"?>
+<p:sld xmlns:a="http://schemas.openxmlformats.org/drawingml/2006/main" xmlns:p="http://schemas.openxmlformats.org/presentationml/2006/main" xmlns:r="http://schemas.openxmlformats.org/officeDocument/2006/relationships">
+  <p:cSld>
+    <p:spTree>
+      <p:nvGrpSpPr>
+        <p:cNvPr id="1" name=""/>
+        <p:cNvGrpSpPr/>
+        <p:nvPr/>
+      </p:nvGrpSpPr>
+      <p:grpSpPr/>
+      <p:pic>
+        <p:nvPicPr>
+          <p:cNvPr id="2" name="Picture 1" descr="slide_16_clean_hero_canvas.png"/>
+          <p:cNvPicPr>
+            <a:picLocks noChangeAspect="1"/>
+          </p:cNvPicPr>
+          <p:nvPr/>
+        </p:nvPicPr>
+        <p:blipFill>
+          <a:blip r:embed="rId2"/>
+          <a:stretch>
+            <a:fillRect/>
+          </a:stretch>
+        </p:blipFill>
+        <p:spPr>
+          <a:xfrm>
+            <a:off x="0" y="0"/>
+            <a:ext cx="12191999" cy="6858000"/>
+          </a:xfrm>
+          <a:prstGeom prst="rect">
+            <a:avLst/>
+          </a:prstGeom>
+        </p:spPr>
+      </p:pic>
+      <p:sp>
+        <p:nvSpPr>
+          <p:cNvPr id="3" name="TextBox 2"/>
+          <p:cNvSpPr txBox="1"/>
+          <p:nvPr/>
+        </p:nvSpPr>
+        <p:spPr>
+          <a:xfrm>
+            <a:off x="621792" y="502920"/>
+            <a:ext cx="5943600" cy="320040"/>
+          </a:xfrm>
+          <a:prstGeom prst="rect">
+            <a:avLst/>
+          </a:prstGeom>
+          <a:noFill/>
+        </p:spPr>
+        <p:txBody>
+          <a:bodyPr wrap="square" lIns="0" tIns="0" rIns="0" bIns="0">
+            <a:spAutoFit/>
+          </a:bodyPr>
+          <a:lstStyle/>
+          <a:p>
+            <a:pPr>
+              <a:defRPr sz="1100" b="1">
+                <a:solidFill>
+                  <a:srgbClr val="C14424"/>
+                </a:solidFill>
+                <a:latin typeface="DejaVu Sans"/>
+              </a:defRPr>
+            </a:pPr>
+            <a:r>
+              <a:t>● NOVEMBER 02—03, 2026 / THE NEST, UBC</a:t>
+            </a:r>
+          </a:p>
+        </p:txBody>
+      </p:sp>
+      <p:sp>
+        <p:nvSpPr>
+          <p:cNvPr id="4" name="TextBox 3"/>
+          <p:cNvSpPr txBox="1"/>
+          <p:nvPr/>
+        </p:nvSpPr>
+        <p:spPr>
+          <a:xfrm>
+            <a:off x="621792" y="960120"/>
+            <a:ext cx="5943600" cy="1645920"/>
+          </a:xfrm>
+          <a:prstGeom prst="rect">
+            <a:avLst/>
+          </a:prstGeom>
+          <a:noFill/>
+        </p:spPr>
+        <p:txBody>
+          <a:bodyPr wrap="square" lIns="0" tIns="0" rIns="0" bIns="0">
+            <a:spAutoFit/>
+          </a:bodyPr>
+          <a:lstStyle/>
+          <a:p>
+            <a:pPr>
+              <a:defRPr sz="3600" b="1">
+                <a:solidFill>
+                  <a:srgbClr val="183440"/>
+                </a:solidFill>
+                <a:latin typeface="DejaVu Sans"/>
+              </a:defRPr>
+            </a:pPr>
+            <a:r>
+              <a:t>Presenting in</a:t>
+            </a:r>
+          </a:p>
+          <a:p>
+            <a:pPr>
+              <a:defRPr sz="3600" b="1">
+                <a:solidFill>
+                  <a:srgbClr val="C14424"/>
+                </a:solidFill>
+                <a:latin typeface="DejaVu Sans"/>
+              </a:defRPr>
+            </a:pPr>
+            <a:r>
+              <a:t>AI Summit Vancouver 2026</a:t>
+            </a:r>
+          </a:p>
+        </p:txBody>
+      </p:sp>
+      <p:sp>
+        <p:nvSpPr>
+          <p:cNvPr id="5" name="TextBox 4"/>
+          <p:cNvSpPr txBox="1"/>
+          <p:nvPr/>
+        </p:nvSpPr>
+        <p:spPr>
+          <a:xfrm>
+            <a:off x="621792" y="2788920"/>
+            <a:ext cx="5943600" cy="1005840"/>
+          </a:xfrm>
+          <a:prstGeom prst="rect">
+            <a:avLst/>
+          </a:prstGeom>
+          <a:noFill/>
+        </p:spPr>
+        <p:txBody>
+          <a:bodyPr wrap="square" lIns="0" tIns="0" rIns="0" bIns="0">
+            <a:spAutoFit/>
+          </a:bodyPr>
+          <a:lstStyle/>
+          <a:p>
+            <a:pPr>
+              <a:defRPr sz="1400">
+                <a:solidFill>
+                  <a:srgbClr val="53676D"/>
+                </a:solidFill>
+                <a:latin typeface="DejaVu Sans"/>
+              </a:defRPr>
+            </a:pPr>
+            <a:r>
+              <a:t>Finux Labs presents dual-agent autonomous negotiation, supplier cost assessment, and pricing intelligence in enterprise procurement.</a:t>
+            </a:r>
+          </a:p>
+        </p:txBody>
+      </p:sp>
+      <p:sp>
+        <p:nvSpPr>
+          <p:cNvPr id="6" name="TextBox 5"/>
+          <p:cNvSpPr txBox="1"/>
+          <p:nvPr/>
+        </p:nvSpPr>
+        <p:spPr>
+          <a:xfrm>
+            <a:off x="621792" y="3977639"/>
+            <a:ext cx="5943600" cy="411480"/>
+          </a:xfrm>
+          <a:prstGeom prst="rect">
+            <a:avLst/>
+          </a:prstGeom>
+          <a:noFill/>
+        </p:spPr>
+        <p:txBody>
+          <a:bodyPr wrap="square" lIns="0" tIns="0" rIns="0" bIns="0">
+            <a:spAutoFit/>
+          </a:bodyPr>
+          <a:lstStyle/>
+          <a:p>
+            <a:pPr>
+              <a:defRPr sz="1100" b="1">
+                <a:solidFill>
+                  <a:srgbClr val="2D4A53"/>
+                </a:solidFill>
+                <a:latin typeface="DejaVu Sans"/>
+              </a:defRPr>
+            </a:pPr>
+            <a:r>
+              <a:t>[ Agentic Procurement ]   [ Dual-Agent Negotiation ]   [ Vancouver, BC ]</a:t>
+            </a:r>
+          </a:p>
+        </p:txBody>
+      </p:sp>
+      <p:sp>
+        <p:nvSpPr>
+          <p:cNvPr id="7" name="Rounded Rectangle 6"/>
+          <p:cNvSpPr/>
+          <p:nvPr/>
+        </p:nvSpPr>
+        <p:spPr>
+          <a:xfrm>
+            <a:off x="621792" y="4663440"/>
+            <a:ext cx="3108960" cy="594360"/>
+          </a:xfrm>
+          <a:prstGeom prst="roundRect">
+            <a:avLst/>
+          </a:prstGeom>
+          <a:solidFill>
+            <a:srgbClr val="183440"/>
+          </a:solidFill>
+          <a:ln>
+            <a:noFill/>
+          </a:ln>
+        </p:spPr>
+        <p:style>
+          <a:lnRef idx="1">
+            <a:schemeClr val="accent1"/>
+          </a:lnRef>
+          <a:fillRef idx="3">
+            <a:schemeClr val="accent1"/>
+          </a:fillRef>
+          <a:effectRef idx="2">
+            <a:schemeClr val="accent1"/>
+          </a:effectRef>
+          <a:fontRef idx="minor">
+            <a:schemeClr val="lt1"/>
+          </a:fontRef>
+        </p:style>
+        <p:txBody>
+          <a:bodyPr rtlCol="0" anchor="ctr" wrap="none"/>
+          <a:lstStyle/>
+          <a:p>
+            <a:pPr algn="ctr"/>
+            <a:r>
+              <a:rPr sz="1300" b="1">
+                <a:solidFill>
+                  <a:srgbClr val="FFFFFF"/>
+                </a:solidFill>
+                <a:latin typeface="DejaVu Sans"/>
+                <a:hlinkClick r:id="rId3"/>
+              </a:rPr>
+              <a:t>Explore Summit Programme ↗</a:t>
+            </a:r>
+          </a:p>
+        </p:txBody>
+      </p:sp>
+      <p:sp>
+        <p:nvSpPr>
+          <p:cNvPr id="8" name="TextBox 7"/>
+          <p:cNvSpPr txBox="1"/>
+          <p:nvPr/>
+        </p:nvSpPr>
+        <p:spPr>
+          <a:xfrm>
+            <a:off x="621792" y="5349240"/>
+            <a:ext cx="5486400" cy="320040"/>
+          </a:xfrm>
+          <a:prstGeom prst="rect">
+            <a:avLst/>
+          </a:prstGeom>
+          <a:noFill/>
+        </p:spPr>
+        <p:txBody>
+          <a:bodyPr wrap="none" lIns="0" tIns="0" rIns="0" bIns="0">
+            <a:spAutoFit/>
+          </a:bodyPr>
+          <a:lstStyle/>
+          <a:p>
+            <a:r>
+              <a:rPr sz="1100" u="sng">
+                <a:solidFill>
+                  <a:srgbClr val="7A8D93"/>
+                </a:solidFill>
+                <a:latin typeface="DejaVu Sans"/>
+                <a:hlinkClick r:id="rId3"/>
+              </a:rPr>
+              <a:t>https://aisummit-vancouver2026.connextium.xyz/</a:t>
+            </a:r>
+          </a:p>
+        </p:txBody>
+      </p:sp>
+      <p:sp>
+        <p:nvSpPr>
+          <p:cNvPr id="9" name="TextBox 8"/>
+          <p:cNvSpPr txBox="1"/>
+          <p:nvPr/>
+        </p:nvSpPr>
+        <p:spPr>
+          <a:xfrm>
+            <a:off x="621792" y="6263640"/>
+            <a:ext cx="2286000" cy="320040"/>
+          </a:xfrm>
+          <a:prstGeom prst="rect">
+            <a:avLst/>
+          </a:prstGeom>
+          <a:noFill/>
+        </p:spPr>
+        <p:txBody>
+          <a:bodyPr wrap="none">
+            <a:spAutoFit/>
+          </a:bodyPr>
+          <a:lstStyle/>
+          <a:p>
+            <a:pPr>
+              <a:defRPr sz="1100" b="1">
+                <a:solidFill>
+                  <a:srgbClr val="6C5CE7"/>
+                </a:solidFill>
+                <a:latin typeface="DejaVu Sans"/>
+              </a:defRPr>
+            </a:pPr>
+            <a:r>
+              <a:t>Finux Labs</a:t>
+            </a:r>
+          </a:p>
+        </p:txBody>
+      </p:sp>
+      <p:sp>
+        <p:nvSpPr>
+          <p:cNvPr id="10" name="TextBox 9"/>
+          <p:cNvSpPr txBox="1"/>
+          <p:nvPr/>
+        </p:nvSpPr>
+        <p:spPr>
+          <a:xfrm>
+            <a:off x="2926080" y="6263640"/>
+            <a:ext cx="6858000" cy="320040"/>
+          </a:xfrm>
+          <a:prstGeom prst="rect">
+            <a:avLst/>
+          </a:prstGeom>
+          <a:noFill/>
+        </p:spPr>
+        <p:txBody>
+          <a:bodyPr wrap="none">
+            <a:spAutoFit/>
+          </a:bodyPr>
+          <a:lstStyle/>
+          <a:p>
+            <a:pPr algn="ctr">
+              <a:defRPr sz="900">
+                <a:solidFill>
+                  <a:srgbClr val="8A96A8"/>
+                </a:solidFill>
+                <a:latin typeface="DejaVu Sans"/>
+              </a:defRPr>
+            </a:pPr>
+            <a:r>
+              <a:t>Connected Intelligence · AI Summit Vancouver 2026 · Connextium Event Companion</a:t>
+            </a:r>
+          </a:p>
+        </p:txBody>
+      </p:sp>
+      <p:sp>
+        <p:nvSpPr>
+          <p:cNvPr id="11" name="TextBox 10"/>
+          <p:cNvSpPr txBox="1"/>
+          <p:nvPr/>
+        </p:nvSpPr>
+        <p:spPr>
+          <a:xfrm>
+            <a:off x="10789920" y="6263640"/>
+            <a:ext cx="731520" cy="320040"/>
+          </a:xfrm>
+          <a:prstGeom prst="rect">
+            <a:avLst/>
+          </a:prstGeom>
+          <a:noFill/>
+        </p:spPr>
+        <p:txBody>
+          <a:bodyPr wrap="none">
+            <a:spAutoFit/>
+          </a:bodyPr>
+          <a:lstStyle/>
+          <a:p>
+            <a:pPr algn="r">
+              <a:defRPr sz="1100" b="1">
+                <a:solidFill>
+                  <a:srgbClr val="8A96A8"/>
+                </a:solidFill>
+                <a:latin typeface="DejaVu Sans"/>
+              </a:defRPr>
+            </a:pPr>
+            <a:r>
+              <a:t>16</a:t>
+            </a:r>
+          </a:p>
+        </p:txBody>
+      </p:sp>
+    </p:spTree>
+  </p:cSld>
+  <p:clrMapOvr>
+    <a:masterClrMapping/>
+  </p:clrMapOvr>
+</p:sld>
+</file>
+
 <file path=ppt/slides/slide2.xml><?xml version="1.0" encoding="utf-8"?>
 <p:sld xmlns:p="http://schemas.openxmlformats.org/presentationml/2006/main">
   <p:cSld>

</xml_diff>

<commit_message>
Remove description paragraph and raw URL from Slide 16 across HTML, PPTX, and PDF
</commit_message>
<xml_diff>
--- a/docs/publish/pitch-agentic-procurement/Finux-Labs-Procurement-AI-Pitch-15-Slides.pptx
+++ b/docs/publish/pitch-agentic-procurement/Finux-Labs-Procurement-AI-Pitch-15-Slides.pptx
@@ -19030,7 +19030,7 @@
         </p:nvSpPr>
         <p:spPr>
           <a:xfrm>
-            <a:off x="621792" y="502920"/>
+            <a:off x="621792" y="868680"/>
             <a:ext cx="5943600" cy="320040"/>
           </a:xfrm>
           <a:prstGeom prst="rect">
@@ -19066,7 +19066,7 @@
         </p:nvSpPr>
         <p:spPr>
           <a:xfrm>
-            <a:off x="621792" y="960120"/>
+            <a:off x="621792" y="1325880"/>
             <a:ext cx="5943600" cy="1645920"/>
           </a:xfrm>
           <a:prstGeom prst="rect">
@@ -19109,49 +19109,13 @@
       </p:sp>
       <p:sp>
         <p:nvSpPr>
-          <p:cNvPr id="5" name="TextBox 4"/>
-          <p:cNvSpPr txBox="1"/>
-          <p:nvPr/>
-        </p:nvSpPr>
-        <p:spPr>
-          <a:xfrm>
-            <a:off x="621792" y="2788920"/>
-            <a:ext cx="5943600" cy="1005840"/>
-          </a:xfrm>
-          <a:prstGeom prst="rect">
-            <a:avLst/>
-          </a:prstGeom>
-          <a:noFill/>
-        </p:spPr>
-        <p:txBody>
-          <a:bodyPr wrap="square" lIns="0" tIns="0" rIns="0" bIns="0">
-            <a:spAutoFit/>
-          </a:bodyPr>
-          <a:lstStyle/>
-          <a:p>
-            <a:pPr>
-              <a:defRPr sz="1400">
-                <a:solidFill>
-                  <a:srgbClr val="53676D"/>
-                </a:solidFill>
-                <a:latin typeface="DejaVu Sans"/>
-              </a:defRPr>
-            </a:pPr>
-            <a:r>
-              <a:t>Finux Labs presents dual-agent autonomous negotiation, supplier cost assessment, and pricing intelligence in enterprise procurement.</a:t>
-            </a:r>
-          </a:p>
-        </p:txBody>
-      </p:sp>
-      <p:sp>
-        <p:nvSpPr>
           <p:cNvPr id="6" name="TextBox 5"/>
           <p:cNvSpPr txBox="1"/>
           <p:nvPr/>
         </p:nvSpPr>
         <p:spPr>
           <a:xfrm>
-            <a:off x="621792" y="3977639"/>
+            <a:off x="621792" y="3383280"/>
             <a:ext cx="5943600" cy="411480"/>
           </a:xfrm>
           <a:prstGeom prst="rect">
@@ -19187,7 +19151,7 @@
         </p:nvSpPr>
         <p:spPr>
           <a:xfrm>
-            <a:off x="621792" y="4663440"/>
+            <a:off x="621792" y="4160520"/>
             <a:ext cx="3108960" cy="594360"/>
           </a:xfrm>
           <a:prstGeom prst="roundRect">
@@ -19228,41 +19192,6 @@
                 <a:hlinkClick r:id="rId3"/>
               </a:rPr>
               <a:t>Explore Summit Programme ↗</a:t>
-            </a:r>
-          </a:p>
-        </p:txBody>
-      </p:sp>
-      <p:sp>
-        <p:nvSpPr>
-          <p:cNvPr id="8" name="TextBox 7"/>
-          <p:cNvSpPr txBox="1"/>
-          <p:nvPr/>
-        </p:nvSpPr>
-        <p:spPr>
-          <a:xfrm>
-            <a:off x="621792" y="5349240"/>
-            <a:ext cx="5486400" cy="320040"/>
-          </a:xfrm>
-          <a:prstGeom prst="rect">
-            <a:avLst/>
-          </a:prstGeom>
-          <a:noFill/>
-        </p:spPr>
-        <p:txBody>
-          <a:bodyPr wrap="none" lIns="0" tIns="0" rIns="0" bIns="0">
-            <a:spAutoFit/>
-          </a:bodyPr>
-          <a:lstStyle/>
-          <a:p>
-            <a:r>
-              <a:rPr sz="1100" u="sng">
-                <a:solidFill>
-                  <a:srgbClr val="7A8D93"/>
-                </a:solidFill>
-                <a:latin typeface="DejaVu Sans"/>
-                <a:hlinkClick r:id="rId3"/>
-              </a:rPr>
-              <a:t>https://aisummit-vancouver2026.connextium.xyz/</a:t>
             </a:r>
           </a:p>
         </p:txBody>

</xml_diff>